<commit_message>
Ana sunum ve konuşma metni yüklendi
</commit_message>
<xml_diff>
--- a/sunum/EAETIS_Staj_Sunumu_Taslak.pptx
+++ b/sunum/EAETIS_Staj_Sunumu_Taslak.pptx
@@ -19,6 +19,7 @@
     <p:sldId id="267" r:id="rId18"/>
     <p:sldId id="268" r:id="rId19"/>
     <p:sldId id="269" r:id="rId20"/>
+    <p:sldId id="270" r:id="rId21"/>
   </p:sldIdLst>
   <p:sldSz cx="12191695" cy="6858000" type="screen4x3"/>
   <p:notesSz cx="6858000" cy="9144000"/>
@@ -3333,7 +3334,7 @@
                 </a:solidFill>
                 <a:latin typeface="Calibri"/>
               </a:rPr>
-              <a:t>10 / 14</a:t>
+              <a:t>10 / 15</a:t>
             </a:r>
           </a:p>
         </p:txBody>
@@ -3969,7 +3970,7 @@
                 </a:solidFill>
                 <a:latin typeface="Calibri"/>
               </a:rPr>
-              <a:t>11 / 14</a:t>
+              <a:t>11 / 15</a:t>
             </a:r>
           </a:p>
         </p:txBody>
@@ -4310,7 +4311,7 @@
                 </a:solidFill>
                 <a:latin typeface="Calibri"/>
               </a:rPr>
-              <a:t>12 / 14</a:t>
+              <a:t>12 / 15</a:t>
             </a:r>
           </a:p>
         </p:txBody>
@@ -4744,7 +4745,7 @@
                 </a:solidFill>
                 <a:latin typeface="Consolas"/>
               </a:rPr>
-              <a:t>12 · ARAÇLAR &amp; TEKNOLOJILER</a:t>
+              <a:t>12 · ENTEGRASYON</a:t>
             </a:r>
           </a:p>
         </p:txBody>
@@ -4778,7 +4779,7 @@
                 </a:solidFill>
                 <a:latin typeface="Calibri"/>
               </a:rPr>
-              <a:t>Tek projede birçok farklı teknolojiyi bir araya getirdim</a:t>
+              <a:t>Başka Bir Kullanıcı Bu Projeyi Nasıl Kullanır?</a:t>
             </a:r>
           </a:p>
         </p:txBody>
@@ -4791,8 +4792,8 @@
         </p:nvSpPr>
         <p:spPr>
           <a:xfrm>
-            <a:off x="502920" y="1417320"/>
-            <a:ext cx="10241280" cy="548640"/>
+            <a:off x="502920" y="6446520"/>
+            <a:ext cx="5486400" cy="274320"/>
           </a:xfrm>
           <a:prstGeom prst="rect">
             <a:avLst/>
@@ -4806,13 +4807,13 @@
           <a:lstStyle/>
           <a:p>
             <a:r>
-              <a:rPr sz="1350" b="0" i="0">
+              <a:rPr sz="900" b="0" i="0">
                 <a:solidFill>
                   <a:srgbClr val="5B6B80"/>
                 </a:solidFill>
                 <a:latin typeface="Calibri"/>
               </a:rPr>
-              <a:t>Sadece C kodu yazmadım; geliştirme ortamından donanım protokollerine kadar birçok konuda uygulamalı pratik yaptım.</a:t>
+              <a:t>E-AETIS · Staj Sunumu</a:t>
             </a:r>
           </a:p>
         </p:txBody>
@@ -4825,8 +4826,8 @@
         </p:nvSpPr>
         <p:spPr>
           <a:xfrm>
-            <a:off x="502920" y="6446520"/>
-            <a:ext cx="5486400" cy="274320"/>
+            <a:off x="10042855" y="6446520"/>
+            <a:ext cx="1828800" cy="274320"/>
           </a:xfrm>
           <a:prstGeom prst="rect">
             <a:avLst/>
@@ -4839,6 +4840,7 @@
           </a:bodyPr>
           <a:lstStyle/>
           <a:p>
+            <a:pPr algn="r"/>
             <a:r>
               <a:rPr sz="900" b="0" i="0">
                 <a:solidFill>
@@ -4846,7 +4848,7 @@
                 </a:solidFill>
                 <a:latin typeface="Calibri"/>
               </a:rPr>
-              <a:t>E-AETIS · Staj Sunumu</a:t>
+              <a:t>13 / 15</a:t>
             </a:r>
           </a:p>
         </p:txBody>
@@ -4859,8 +4861,8 @@
         </p:nvSpPr>
         <p:spPr>
           <a:xfrm>
-            <a:off x="10042855" y="6446520"/>
-            <a:ext cx="1828800" cy="274320"/>
+            <a:off x="502920" y="1463040"/>
+            <a:ext cx="5464911" cy="201168"/>
           </a:xfrm>
           <a:prstGeom prst="rect">
             <a:avLst/>
@@ -4873,15 +4875,14 @@
           </a:bodyPr>
           <a:lstStyle/>
           <a:p>
-            <a:pPr algn="r"/>
-            <a:r>
-              <a:rPr sz="900" b="0" i="0">
-                <a:solidFill>
-                  <a:srgbClr val="5B6B80"/>
-                </a:solidFill>
-                <a:latin typeface="Calibri"/>
-              </a:rPr>
-              <a:t>13 / 14</a:t>
+            <a:r>
+              <a:rPr sz="950" b="1" i="0">
+                <a:solidFill>
+                  <a:srgbClr val="0E93B4"/>
+                </a:solidFill>
+                <a:latin typeface="Consolas"/>
+              </a:rPr>
+              <a:t>ETH_CONFIG.H  ·  SEÇIM</a:t>
             </a:r>
           </a:p>
         </p:txBody>
@@ -4894,21 +4895,19 @@
         </p:nvSpPr>
         <p:spPr>
           <a:xfrm>
-            <a:off x="502920" y="2103120"/>
-            <a:ext cx="5455767" cy="2834640"/>
+            <a:off x="502920" y="1700784"/>
+            <a:ext cx="5464911" cy="2080260"/>
           </a:xfrm>
           <a:prstGeom prst="roundRect">
             <a:avLst>
-              <a:gd name="adj" fmla="val 4500"/>
+              <a:gd name="adj" fmla="val 3500"/>
             </a:avLst>
           </a:prstGeom>
           <a:solidFill>
-            <a:srgbClr val="F6F8FB"/>
+            <a:srgbClr val="10233F"/>
           </a:solidFill>
-          <a:ln w="12700">
-            <a:solidFill>
-              <a:srgbClr val="DBE1EA"/>
-            </a:solidFill>
+          <a:ln>
+            <a:noFill/>
           </a:ln>
           <a:effectLst/>
         </p:spPr>
@@ -4942,8 +4941,8 @@
         </p:nvSpPr>
         <p:spPr>
           <a:xfrm>
-            <a:off x="704088" y="2304288"/>
-            <a:ext cx="5053431" cy="219456"/>
+            <a:off x="704088" y="1901952"/>
+            <a:ext cx="5062575" cy="1677924"/>
           </a:xfrm>
           <a:prstGeom prst="rect">
             <a:avLst/>
@@ -4956,14 +4955,147 @@
           </a:bodyPr>
           <a:lstStyle/>
           <a:p>
-            <a:r>
-              <a:rPr sz="950" b="1" i="0">
-                <a:solidFill>
-                  <a:srgbClr val="0E93B4"/>
+            <a:pPr>
+              <a:spcAft>
+                <a:spcPts val="100"/>
+              </a:spcAft>
+            </a:pPr>
+            <a:r>
+              <a:rPr sz="900" b="0" i="0">
+                <a:solidFill>
+                  <a:srgbClr val="DBE8FB"/>
                 </a:solidFill>
                 <a:latin typeface="Consolas"/>
               </a:rPr>
-              <a:t>GELIŞTIRME ORTAMI</a:t>
+              <a:t>/* 1) Hedef islemci (sadece birini birakin) */</a:t>
+            </a:r>
+          </a:p>
+          <a:p>
+            <a:pPr>
+              <a:spcAft>
+                <a:spcPts val="100"/>
+              </a:spcAft>
+            </a:pPr>
+            <a:r>
+              <a:rPr sz="900" b="0" i="0">
+                <a:solidFill>
+                  <a:srgbClr val="DBE8FB"/>
+                </a:solidFill>
+                <a:latin typeface="Consolas"/>
+              </a:rPr>
+              <a:t>#define ETH_TARGET_STM32H563</a:t>
+            </a:r>
+          </a:p>
+          <a:p>
+            <a:pPr>
+              <a:spcAft>
+                <a:spcPts val="100"/>
+              </a:spcAft>
+            </a:pPr>
+            <a:r>
+              <a:rPr sz="900" b="0" i="0">
+                <a:solidFill>
+                  <a:srgbClr val="DBE8FB"/>
+                </a:solidFill>
+                <a:latin typeface="Consolas"/>
+              </a:rPr>
+              <a:t>/* #define ETH_TARGET_STM32H743 */</a:t>
+            </a:r>
+          </a:p>
+          <a:p>
+            <a:pPr>
+              <a:spcAft>
+                <a:spcPts val="100"/>
+              </a:spcAft>
+            </a:pPr>
+            <a:r>
+              <a:rPr sz="900" b="0" i="0">
+                <a:solidFill>
+                  <a:srgbClr val="DBE8FB"/>
+                </a:solidFill>
+                <a:latin typeface="Consolas"/>
+              </a:rPr>
+              <a:t>/* #define ETH_TARGET_STM32F407 */</a:t>
+            </a:r>
+          </a:p>
+          <a:p>
+            <a:pPr>
+              <a:spcAft>
+                <a:spcPts val="100"/>
+              </a:spcAft>
+            </a:pPr>
+            <a:r>
+              <a:rPr sz="900" b="0" i="0">
+                <a:solidFill>
+                  <a:srgbClr val="DBE8FB"/>
+                </a:solidFill>
+                <a:latin typeface="Consolas"/>
+              </a:rPr>
+              <a:t> </a:t>
+            </a:r>
+          </a:p>
+          <a:p>
+            <a:pPr>
+              <a:spcAft>
+                <a:spcPts val="100"/>
+              </a:spcAft>
+            </a:pPr>
+            <a:r>
+              <a:rPr sz="900" b="0" i="0">
+                <a:solidFill>
+                  <a:srgbClr val="DBE8FB"/>
+                </a:solidFill>
+                <a:latin typeface="Consolas"/>
+              </a:rPr>
+              <a:t>/* 2) PHY cipi (sadece birini birakin) */</a:t>
+            </a:r>
+          </a:p>
+          <a:p>
+            <a:pPr>
+              <a:spcAft>
+                <a:spcPts val="100"/>
+              </a:spcAft>
+            </a:pPr>
+            <a:r>
+              <a:rPr sz="900" b="0" i="0">
+                <a:solidFill>
+                  <a:srgbClr val="DBE8FB"/>
+                </a:solidFill>
+                <a:latin typeface="Consolas"/>
+              </a:rPr>
+              <a:t>#define ETH_PHY_LAN8720A</a:t>
+            </a:r>
+          </a:p>
+          <a:p>
+            <a:pPr>
+              <a:spcAft>
+                <a:spcPts val="100"/>
+              </a:spcAft>
+            </a:pPr>
+            <a:r>
+              <a:rPr sz="900" b="0" i="0">
+                <a:solidFill>
+                  <a:srgbClr val="DBE8FB"/>
+                </a:solidFill>
+                <a:latin typeface="Consolas"/>
+              </a:rPr>
+              <a:t>/* #define ETH_PHY_LAN8742A */</a:t>
+            </a:r>
+          </a:p>
+          <a:p>
+            <a:pPr>
+              <a:spcAft>
+                <a:spcPts val="100"/>
+              </a:spcAft>
+            </a:pPr>
+            <a:r>
+              <a:rPr sz="900" b="0" i="0">
+                <a:solidFill>
+                  <a:srgbClr val="DBE8FB"/>
+                </a:solidFill>
+                <a:latin typeface="Consolas"/>
+              </a:rPr>
+              <a:t>/* #define ETH_PHY_KSZ8081  */</a:t>
             </a:r>
           </a:p>
         </p:txBody>
@@ -4976,8 +5108,8 @@
         </p:nvSpPr>
         <p:spPr>
           <a:xfrm>
-            <a:off x="704088" y="2578608"/>
-            <a:ext cx="5053431" cy="320040"/>
+            <a:off x="6223863" y="1463040"/>
+            <a:ext cx="5464911" cy="201168"/>
           </a:xfrm>
           <a:prstGeom prst="rect">
             <a:avLst/>
@@ -4991,13 +5123,13 @@
           <a:lstStyle/>
           <a:p>
             <a:r>
-              <a:rPr sz="1500" b="1" i="0">
-                <a:solidFill>
-                  <a:srgbClr val="101826"/>
-                </a:solidFill>
-                <a:latin typeface="Calibri"/>
-              </a:rPr>
-              <a:t>Araçlar &amp; İş Akışı</a:t>
+              <a:rPr sz="950" b="1" i="0">
+                <a:solidFill>
+                  <a:srgbClr val="0E93B4"/>
+                </a:solidFill>
+                <a:latin typeface="Consolas"/>
+              </a:rPr>
+              <a:t>MAIN.C  ·  BAŞLATMA</a:t>
             </a:r>
           </a:p>
         </p:txBody>
@@ -5010,21 +5142,19 @@
         </p:nvSpPr>
         <p:spPr>
           <a:xfrm>
-            <a:off x="704088" y="2962656"/>
-            <a:ext cx="914400" cy="274320"/>
+            <a:off x="6223863" y="1700784"/>
+            <a:ext cx="5464911" cy="2080260"/>
           </a:xfrm>
           <a:prstGeom prst="roundRect">
             <a:avLst>
-              <a:gd name="adj" fmla="val 50000"/>
+              <a:gd name="adj" fmla="val 3500"/>
             </a:avLst>
           </a:prstGeom>
           <a:solidFill>
-            <a:srgbClr val="E7ECF5"/>
+            <a:srgbClr val="10233F"/>
           </a:solidFill>
-          <a:ln w="9525">
-            <a:solidFill>
-              <a:srgbClr val="004694"/>
-            </a:solidFill>
+          <a:ln>
+            <a:noFill/>
           </a:ln>
           <a:effectLst/>
         </p:spPr>
@@ -5043,45 +5173,267 @@
           </a:fontRef>
         </p:style>
         <p:txBody>
-          <a:bodyPr rtlCol="0" anchor="ctr" lIns="0" rIns="0" tIns="0" bIns="0"/>
+          <a:bodyPr rtlCol="0" anchor="ctr"/>
           <a:lstStyle/>
           <a:p>
             <a:pPr algn="ctr"/>
-            <a:r>
-              <a:rPr sz="1000" b="1" i="0">
-                <a:solidFill>
-                  <a:srgbClr val="004694"/>
+          </a:p>
+        </p:txBody>
+      </p:sp>
+      <p:sp>
+        <p:nvSpPr>
+          <p:cNvPr id="12" name="TextBox 11"/>
+          <p:cNvSpPr txBox="1"/>
+          <p:nvPr/>
+        </p:nvSpPr>
+        <p:spPr>
+          <a:xfrm>
+            <a:off x="6425031" y="1901952"/>
+            <a:ext cx="5062575" cy="1677924"/>
+          </a:xfrm>
+          <a:prstGeom prst="rect">
+            <a:avLst/>
+          </a:prstGeom>
+          <a:noFill/>
+        </p:spPr>
+        <p:txBody>
+          <a:bodyPr wrap="square" lIns="0" rIns="0" tIns="0" bIns="0">
+            <a:spAutoFit/>
+          </a:bodyPr>
+          <a:lstStyle/>
+          <a:p>
+            <a:pPr>
+              <a:spcAft>
+                <a:spcPts val="100"/>
+              </a:spcAft>
+            </a:pPr>
+            <a:r>
+              <a:rPr sz="900" b="0" i="0">
+                <a:solidFill>
+                  <a:srgbClr val="DBE8FB"/>
                 </a:solidFill>
                 <a:latin typeface="Consolas"/>
               </a:rPr>
-              <a:t>CMake</a:t>
-            </a:r>
-          </a:p>
-        </p:txBody>
-      </p:sp>
-      <p:sp>
-        <p:nvSpPr>
-          <p:cNvPr id="12" name="Rounded Rectangle 11"/>
+              <a:t>#include "eth_app.h"</a:t>
+            </a:r>
+          </a:p>
+          <a:p>
+            <a:pPr>
+              <a:spcAft>
+                <a:spcPts val="100"/>
+              </a:spcAft>
+            </a:pPr>
+            <a:r>
+              <a:rPr sz="900" b="0" i="0">
+                <a:solidFill>
+                  <a:srgbClr val="DBE8FB"/>
+                </a:solidFill>
+                <a:latin typeface="Consolas"/>
+              </a:rPr>
+              <a:t> </a:t>
+            </a:r>
+          </a:p>
+          <a:p>
+            <a:pPr>
+              <a:spcAft>
+                <a:spcPts val="100"/>
+              </a:spcAft>
+            </a:pPr>
+            <a:r>
+              <a:rPr sz="900" b="0" i="0">
+                <a:solidFill>
+                  <a:srgbClr val="DBE8FB"/>
+                </a:solidFill>
+                <a:latin typeface="Consolas"/>
+              </a:rPr>
+              <a:t>int main(void) {</a:t>
+            </a:r>
+          </a:p>
+          <a:p>
+            <a:pPr>
+              <a:spcAft>
+                <a:spcPts val="100"/>
+              </a:spcAft>
+            </a:pPr>
+            <a:r>
+              <a:rPr sz="900" b="0" i="0">
+                <a:solidFill>
+                  <a:srgbClr val="DBE8FB"/>
+                </a:solidFill>
+                <a:latin typeface="Consolas"/>
+              </a:rPr>
+              <a:t>    HAL_Init();</a:t>
+            </a:r>
+          </a:p>
+          <a:p>
+            <a:pPr>
+              <a:spcAft>
+                <a:spcPts val="100"/>
+              </a:spcAft>
+            </a:pPr>
+            <a:r>
+              <a:rPr sz="900" b="0" i="0">
+                <a:solidFill>
+                  <a:srgbClr val="DBE8FB"/>
+                </a:solidFill>
+                <a:latin typeface="Consolas"/>
+              </a:rPr>
+              <a:t>    SystemClock_Config();</a:t>
+            </a:r>
+          </a:p>
+          <a:p>
+            <a:pPr>
+              <a:spcAft>
+                <a:spcPts val="100"/>
+              </a:spcAft>
+            </a:pPr>
+            <a:r>
+              <a:rPr sz="900" b="0" i="0">
+                <a:solidFill>
+                  <a:srgbClr val="DBE8FB"/>
+                </a:solidFill>
+                <a:latin typeface="Consolas"/>
+              </a:rPr>
+              <a:t>    ETH_BSP_Init();</a:t>
+            </a:r>
+          </a:p>
+          <a:p>
+            <a:pPr>
+              <a:spcAft>
+                <a:spcPts val="100"/>
+              </a:spcAft>
+            </a:pPr>
+            <a:r>
+              <a:rPr sz="900" b="0" i="0">
+                <a:solidFill>
+                  <a:srgbClr val="DBE8FB"/>
+                </a:solidFill>
+                <a:latin typeface="Consolas"/>
+              </a:rPr>
+              <a:t> </a:t>
+            </a:r>
+          </a:p>
+          <a:p>
+            <a:pPr>
+              <a:spcAft>
+                <a:spcPts val="100"/>
+              </a:spcAft>
+            </a:pPr>
+            <a:r>
+              <a:rPr sz="900" b="0" i="0">
+                <a:solidFill>
+                  <a:srgbClr val="DBE8FB"/>
+                </a:solidFill>
+                <a:latin typeface="Consolas"/>
+              </a:rPr>
+              <a:t>    while (1) {</a:t>
+            </a:r>
+          </a:p>
+          <a:p>
+            <a:pPr>
+              <a:spcAft>
+                <a:spcPts val="100"/>
+              </a:spcAft>
+            </a:pPr>
+            <a:r>
+              <a:rPr sz="900" b="0" i="0">
+                <a:solidFill>
+                  <a:srgbClr val="DBE8FB"/>
+                </a:solidFill>
+                <a:latin typeface="Consolas"/>
+              </a:rPr>
+              <a:t>        ETH_BSP_ProcessEvents();</a:t>
+            </a:r>
+          </a:p>
+          <a:p>
+            <a:pPr>
+              <a:spcAft>
+                <a:spcPts val="100"/>
+              </a:spcAft>
+            </a:pPr>
+            <a:r>
+              <a:rPr sz="900" b="0" i="0">
+                <a:solidFill>
+                  <a:srgbClr val="DBE8FB"/>
+                </a:solidFill>
+                <a:latin typeface="Consolas"/>
+              </a:rPr>
+              <a:t>    }</a:t>
+            </a:r>
+          </a:p>
+          <a:p>
+            <a:pPr>
+              <a:spcAft>
+                <a:spcPts val="100"/>
+              </a:spcAft>
+            </a:pPr>
+            <a:r>
+              <a:rPr sz="900" b="0" i="0">
+                <a:solidFill>
+                  <a:srgbClr val="DBE8FB"/>
+                </a:solidFill>
+                <a:latin typeface="Consolas"/>
+              </a:rPr>
+              <a:t>}</a:t>
+            </a:r>
+          </a:p>
+        </p:txBody>
+      </p:sp>
+      <p:sp>
+        <p:nvSpPr>
+          <p:cNvPr id="13" name="TextBox 12"/>
+          <p:cNvSpPr txBox="1"/>
+          <p:nvPr/>
+        </p:nvSpPr>
+        <p:spPr>
+          <a:xfrm>
+            <a:off x="502920" y="4037076"/>
+            <a:ext cx="5464911" cy="201168"/>
+          </a:xfrm>
+          <a:prstGeom prst="rect">
+            <a:avLst/>
+          </a:prstGeom>
+          <a:noFill/>
+        </p:spPr>
+        <p:txBody>
+          <a:bodyPr wrap="square" lIns="0" rIns="0" tIns="0" bIns="0">
+            <a:spAutoFit/>
+          </a:bodyPr>
+          <a:lstStyle/>
+          <a:p>
+            <a:r>
+              <a:rPr sz="950" b="1" i="0">
+                <a:solidFill>
+                  <a:srgbClr val="0E93B4"/>
+                </a:solidFill>
+                <a:latin typeface="Consolas"/>
+              </a:rPr>
+              <a:t>ETH_DEVICE.H  ·  YENI MCU EKLEME</a:t>
+            </a:r>
+          </a:p>
+        </p:txBody>
+      </p:sp>
+      <p:sp>
+        <p:nvSpPr>
+          <p:cNvPr id="14" name="Rounded Rectangle 13"/>
           <p:cNvSpPr/>
           <p:nvPr/>
         </p:nvSpPr>
         <p:spPr>
           <a:xfrm>
-            <a:off x="1728216" y="2962656"/>
-            <a:ext cx="676656" cy="274320"/>
+            <a:off x="502920" y="4274820"/>
+            <a:ext cx="5464911" cy="2080260"/>
           </a:xfrm>
           <a:prstGeom prst="roundRect">
             <a:avLst>
-              <a:gd name="adj" fmla="val 50000"/>
+              <a:gd name="adj" fmla="val 3500"/>
             </a:avLst>
           </a:prstGeom>
           <a:solidFill>
-            <a:srgbClr val="E7ECF5"/>
+            <a:srgbClr val="10233F"/>
           </a:solidFill>
-          <a:ln w="9525">
-            <a:solidFill>
-              <a:srgbClr val="004694"/>
-            </a:solidFill>
+          <a:ln>
+            <a:noFill/>
           </a:ln>
           <a:effectLst/>
         </p:spPr>
@@ -5100,45 +5452,203 @@
           </a:fontRef>
         </p:style>
         <p:txBody>
-          <a:bodyPr rtlCol="0" anchor="ctr" lIns="0" rIns="0" tIns="0" bIns="0"/>
+          <a:bodyPr rtlCol="0" anchor="ctr"/>
           <a:lstStyle/>
           <a:p>
             <a:pPr algn="ctr"/>
-            <a:r>
-              <a:rPr sz="1000" b="1" i="0">
-                <a:solidFill>
-                  <a:srgbClr val="004694"/>
+          </a:p>
+        </p:txBody>
+      </p:sp>
+      <p:sp>
+        <p:nvSpPr>
+          <p:cNvPr id="15" name="TextBox 14"/>
+          <p:cNvSpPr txBox="1"/>
+          <p:nvPr/>
+        </p:nvSpPr>
+        <p:spPr>
+          <a:xfrm>
+            <a:off x="704088" y="4475988"/>
+            <a:ext cx="5062575" cy="1677924"/>
+          </a:xfrm>
+          <a:prstGeom prst="rect">
+            <a:avLst/>
+          </a:prstGeom>
+          <a:noFill/>
+        </p:spPr>
+        <p:txBody>
+          <a:bodyPr wrap="square" lIns="0" rIns="0" tIns="0" bIns="0">
+            <a:spAutoFit/>
+          </a:bodyPr>
+          <a:lstStyle/>
+          <a:p>
+            <a:pPr>
+              <a:spcAft>
+                <a:spcPts val="100"/>
+              </a:spcAft>
+            </a:pPr>
+            <a:r>
+              <a:rPr sz="900" b="0" i="0">
+                <a:solidFill>
+                  <a:srgbClr val="DBE8FB"/>
                 </a:solidFill>
                 <a:latin typeface="Consolas"/>
               </a:rPr>
-              <a:t>Git</a:t>
-            </a:r>
-          </a:p>
-        </p:txBody>
-      </p:sp>
-      <p:sp>
-        <p:nvSpPr>
-          <p:cNvPr id="13" name="Rounded Rectangle 12"/>
+              <a:t>#elif defined(ETH_TARGET_STM32F429)</a:t>
+            </a:r>
+          </a:p>
+          <a:p>
+            <a:pPr>
+              <a:spcAft>
+                <a:spcPts val="100"/>
+              </a:spcAft>
+            </a:pPr>
+            <a:r>
+              <a:rPr sz="900" b="0" i="0">
+                <a:solidFill>
+                  <a:srgbClr val="DBE8FB"/>
+                </a:solidFill>
+                <a:latin typeface="Consolas"/>
+              </a:rPr>
+              <a:t>  #include "stm32f4xx.h"</a:t>
+            </a:r>
+          </a:p>
+          <a:p>
+            <a:pPr>
+              <a:spcAft>
+                <a:spcPts val="100"/>
+              </a:spcAft>
+            </a:pPr>
+            <a:r>
+              <a:rPr sz="900" b="0" i="0">
+                <a:solidFill>
+                  <a:srgbClr val="DBE8FB"/>
+                </a:solidFill>
+                <a:latin typeface="Consolas"/>
+              </a:rPr>
+              <a:t>  #define ETH_PORT_EQOS          0</a:t>
+            </a:r>
+          </a:p>
+          <a:p>
+            <a:pPr>
+              <a:spcAft>
+                <a:spcPts val="100"/>
+              </a:spcAft>
+            </a:pPr>
+            <a:r>
+              <a:rPr sz="900" b="0" i="0">
+                <a:solidFill>
+                  <a:srgbClr val="DBE8FB"/>
+                </a:solidFill>
+                <a:latin typeface="Consolas"/>
+              </a:rPr>
+              <a:t>  #define ETH_PORT_GMAC          1</a:t>
+            </a:r>
+          </a:p>
+          <a:p>
+            <a:pPr>
+              <a:spcAft>
+                <a:spcPts val="100"/>
+              </a:spcAft>
+            </a:pPr>
+            <a:r>
+              <a:rPr sz="900" b="0" i="0">
+                <a:solidFill>
+                  <a:srgbClr val="DBE8FB"/>
+                </a:solidFill>
+                <a:latin typeface="Consolas"/>
+              </a:rPr>
+              <a:t>  #define ETH_HAS_DCACHE         0</a:t>
+            </a:r>
+          </a:p>
+          <a:p>
+            <a:pPr>
+              <a:spcAft>
+                <a:spcPts val="100"/>
+              </a:spcAft>
+            </a:pPr>
+            <a:r>
+              <a:rPr sz="900" b="0" i="0">
+                <a:solidFill>
+                  <a:srgbClr val="DBE8FB"/>
+                </a:solidFill>
+                <a:latin typeface="Consolas"/>
+              </a:rPr>
+              <a:t>  #define ETH_RMII_VIA_SYSCFG_PMC 1</a:t>
+            </a:r>
+          </a:p>
+          <a:p>
+            <a:pPr>
+              <a:spcAft>
+                <a:spcPts val="100"/>
+              </a:spcAft>
+            </a:pPr>
+            <a:r>
+              <a:rPr sz="900" b="0" i="0">
+                <a:solidFill>
+                  <a:srgbClr val="DBE8FB"/>
+                </a:solidFill>
+                <a:latin typeface="Consolas"/>
+              </a:rPr>
+              <a:t>  #define ETH_DEVICE_NAME        "STM32F429"</a:t>
+            </a:r>
+          </a:p>
+        </p:txBody>
+      </p:sp>
+      <p:sp>
+        <p:nvSpPr>
+          <p:cNvPr id="16" name="TextBox 15"/>
+          <p:cNvSpPr txBox="1"/>
+          <p:nvPr/>
+        </p:nvSpPr>
+        <p:spPr>
+          <a:xfrm>
+            <a:off x="6223863" y="4037076"/>
+            <a:ext cx="5464911" cy="201168"/>
+          </a:xfrm>
+          <a:prstGeom prst="rect">
+            <a:avLst/>
+          </a:prstGeom>
+          <a:noFill/>
+        </p:spPr>
+        <p:txBody>
+          <a:bodyPr wrap="square" lIns="0" rIns="0" tIns="0" bIns="0">
+            <a:spAutoFit/>
+          </a:bodyPr>
+          <a:lstStyle/>
+          <a:p>
+            <a:r>
+              <a:rPr sz="950" b="1" i="0">
+                <a:solidFill>
+                  <a:srgbClr val="0E93B4"/>
+                </a:solidFill>
+                <a:latin typeface="Consolas"/>
+              </a:rPr>
+              <a:t>ETH_PHY_YENI.C  ·  YENI PHY EKLEME</a:t>
+            </a:r>
+          </a:p>
+        </p:txBody>
+      </p:sp>
+      <p:sp>
+        <p:nvSpPr>
+          <p:cNvPr id="17" name="Rounded Rectangle 16"/>
           <p:cNvSpPr/>
           <p:nvPr/>
         </p:nvSpPr>
         <p:spPr>
           <a:xfrm>
-            <a:off x="2514600" y="2962656"/>
-            <a:ext cx="1627632" cy="274320"/>
+            <a:off x="6223863" y="4274820"/>
+            <a:ext cx="5464911" cy="2080260"/>
           </a:xfrm>
           <a:prstGeom prst="roundRect">
             <a:avLst>
-              <a:gd name="adj" fmla="val 50000"/>
+              <a:gd name="adj" fmla="val 3500"/>
             </a:avLst>
           </a:prstGeom>
           <a:solidFill>
-            <a:srgbClr val="E7ECF5"/>
+            <a:srgbClr val="10233F"/>
           </a:solidFill>
-          <a:ln w="9525">
-            <a:solidFill>
-              <a:srgbClr val="004694"/>
-            </a:solidFill>
+          <a:ln>
+            <a:noFill/>
           </a:ln>
           <a:effectLst/>
         </p:spPr>
@@ -5157,194 +5667,23 @@
           </a:fontRef>
         </p:style>
         <p:txBody>
-          <a:bodyPr rtlCol="0" anchor="ctr" lIns="0" rIns="0" tIns="0" bIns="0"/>
+          <a:bodyPr rtlCol="0" anchor="ctr"/>
           <a:lstStyle/>
           <a:p>
             <a:pPr algn="ctr"/>
-            <a:r>
-              <a:rPr sz="1000" b="1" i="0">
-                <a:solidFill>
-                  <a:srgbClr val="004694"/>
-                </a:solidFill>
-                <a:latin typeface="Consolas"/>
-              </a:rPr>
-              <a:t>GCC &amp; Ninja</a:t>
-            </a:r>
-          </a:p>
-        </p:txBody>
-      </p:sp>
-      <p:sp>
-        <p:nvSpPr>
-          <p:cNvPr id="14" name="Rounded Rectangle 13"/>
-          <p:cNvSpPr/>
-          <p:nvPr/>
-        </p:nvSpPr>
-        <p:spPr>
-          <a:xfrm>
-            <a:off x="704088" y="3291840"/>
-            <a:ext cx="1627632" cy="274320"/>
-          </a:xfrm>
-          <a:prstGeom prst="roundRect">
-            <a:avLst>
-              <a:gd name="adj" fmla="val 50000"/>
-            </a:avLst>
-          </a:prstGeom>
-          <a:solidFill>
-            <a:srgbClr val="E7ECF5"/>
-          </a:solidFill>
-          <a:ln w="9525">
-            <a:solidFill>
-              <a:srgbClr val="004694"/>
-            </a:solidFill>
-          </a:ln>
-          <a:effectLst/>
-        </p:spPr>
-        <p:style>
-          <a:lnRef idx="1">
-            <a:schemeClr val="accent1"/>
-          </a:lnRef>
-          <a:fillRef idx="3">
-            <a:schemeClr val="accent1"/>
-          </a:fillRef>
-          <a:effectRef idx="2">
-            <a:schemeClr val="accent1"/>
-          </a:effectRef>
-          <a:fontRef idx="minor">
-            <a:schemeClr val="lt1"/>
-          </a:fontRef>
-        </p:style>
-        <p:txBody>
-          <a:bodyPr rtlCol="0" anchor="ctr" lIns="0" rIns="0" tIns="0" bIns="0"/>
-          <a:lstStyle/>
-          <a:p>
-            <a:pPr algn="ctr"/>
-            <a:r>
-              <a:rPr sz="1000" b="1" i="0">
-                <a:solidFill>
-                  <a:srgbClr val="004694"/>
-                </a:solidFill>
-                <a:latin typeface="Consolas"/>
-              </a:rPr>
-              <a:t>STM32CubeMX</a:t>
-            </a:r>
-          </a:p>
-        </p:txBody>
-      </p:sp>
-      <p:sp>
-        <p:nvSpPr>
-          <p:cNvPr id="15" name="Rounded Rectangle 14"/>
-          <p:cNvSpPr/>
-          <p:nvPr/>
-        </p:nvSpPr>
-        <p:spPr>
-          <a:xfrm>
-            <a:off x="2441448" y="3291840"/>
-            <a:ext cx="1152144" cy="274320"/>
-          </a:xfrm>
-          <a:prstGeom prst="roundRect">
-            <a:avLst>
-              <a:gd name="adj" fmla="val 50000"/>
-            </a:avLst>
-          </a:prstGeom>
-          <a:solidFill>
-            <a:srgbClr val="E7ECF5"/>
-          </a:solidFill>
-          <a:ln w="9525">
-            <a:solidFill>
-              <a:srgbClr val="004694"/>
-            </a:solidFill>
-          </a:ln>
-          <a:effectLst/>
-        </p:spPr>
-        <p:style>
-          <a:lnRef idx="1">
-            <a:schemeClr val="accent1"/>
-          </a:lnRef>
-          <a:fillRef idx="3">
-            <a:schemeClr val="accent1"/>
-          </a:fillRef>
-          <a:effectRef idx="2">
-            <a:schemeClr val="accent1"/>
-          </a:effectRef>
-          <a:fontRef idx="minor">
-            <a:schemeClr val="lt1"/>
-          </a:fontRef>
-        </p:style>
-        <p:txBody>
-          <a:bodyPr rtlCol="0" anchor="ctr" lIns="0" rIns="0" tIns="0" bIns="0"/>
-          <a:lstStyle/>
-          <a:p>
-            <a:pPr algn="ctr"/>
-            <a:r>
-              <a:rPr sz="1000" b="1" i="0">
-                <a:solidFill>
-                  <a:srgbClr val="004694"/>
-                </a:solidFill>
-                <a:latin typeface="Consolas"/>
-              </a:rPr>
-              <a:t>VS Code</a:t>
-            </a:r>
-          </a:p>
-        </p:txBody>
-      </p:sp>
-      <p:sp>
-        <p:nvSpPr>
-          <p:cNvPr id="16" name="Rounded Rectangle 15"/>
-          <p:cNvSpPr/>
-          <p:nvPr/>
-        </p:nvSpPr>
-        <p:spPr>
-          <a:xfrm>
-            <a:off x="6233007" y="2103120"/>
-            <a:ext cx="5455767" cy="2834640"/>
-          </a:xfrm>
-          <a:prstGeom prst="roundRect">
-            <a:avLst>
-              <a:gd name="adj" fmla="val 4500"/>
-            </a:avLst>
-          </a:prstGeom>
-          <a:solidFill>
-            <a:srgbClr val="F6F8FB"/>
-          </a:solidFill>
-          <a:ln w="12700">
-            <a:solidFill>
-              <a:srgbClr val="DBE1EA"/>
-            </a:solidFill>
-          </a:ln>
-          <a:effectLst/>
-        </p:spPr>
-        <p:style>
-          <a:lnRef idx="1">
-            <a:schemeClr val="accent1"/>
-          </a:lnRef>
-          <a:fillRef idx="3">
-            <a:schemeClr val="accent1"/>
-          </a:fillRef>
-          <a:effectRef idx="2">
-            <a:schemeClr val="accent1"/>
-          </a:effectRef>
-          <a:fontRef idx="minor">
-            <a:schemeClr val="lt1"/>
-          </a:fontRef>
-        </p:style>
-        <p:txBody>
-          <a:bodyPr rtlCol="0" anchor="ctr"/>
-          <a:lstStyle/>
-          <a:p>
-            <a:pPr algn="ctr"/>
-          </a:p>
-        </p:txBody>
-      </p:sp>
-      <p:sp>
-        <p:nvSpPr>
-          <p:cNvPr id="17" name="TextBox 16"/>
+          </a:p>
+        </p:txBody>
+      </p:sp>
+      <p:sp>
+        <p:nvSpPr>
+          <p:cNvPr id="18" name="TextBox 17"/>
           <p:cNvSpPr txBox="1"/>
           <p:nvPr/>
         </p:nvSpPr>
         <p:spPr>
           <a:xfrm>
-            <a:off x="6434175" y="2304288"/>
-            <a:ext cx="5053431" cy="219456"/>
+            <a:off x="6425031" y="4475988"/>
+            <a:ext cx="5062575" cy="1677924"/>
           </a:xfrm>
           <a:prstGeom prst="rect">
             <a:avLst/>
@@ -5357,482 +5696,147 @@
           </a:bodyPr>
           <a:lstStyle/>
           <a:p>
-            <a:r>
-              <a:rPr sz="950" b="1" i="0">
-                <a:solidFill>
-                  <a:srgbClr val="0E93B4"/>
+            <a:pPr>
+              <a:spcAft>
+                <a:spcPts val="100"/>
+              </a:spcAft>
+            </a:pPr>
+            <a:r>
+              <a:rPr sz="900" b="0" i="0">
+                <a:solidFill>
+                  <a:srgbClr val="DBE8FB"/>
                 </a:solidFill>
                 <a:latin typeface="Consolas"/>
               </a:rPr>
-              <a:t>DONANIM &amp; PROTOKOLLER</a:t>
-            </a:r>
-          </a:p>
-        </p:txBody>
-      </p:sp>
-      <p:sp>
-        <p:nvSpPr>
-          <p:cNvPr id="18" name="TextBox 17"/>
-          <p:cNvSpPr txBox="1"/>
-          <p:nvPr/>
-        </p:nvSpPr>
-        <p:spPr>
-          <a:xfrm>
-            <a:off x="6434175" y="2578608"/>
-            <a:ext cx="5053431" cy="320040"/>
-          </a:xfrm>
-          <a:prstGeom prst="rect">
-            <a:avLst/>
-          </a:prstGeom>
-          <a:noFill/>
-        </p:spPr>
-        <p:txBody>
-          <a:bodyPr wrap="square" lIns="0" rIns="0" tIns="0" bIns="0">
-            <a:spAutoFit/>
-          </a:bodyPr>
-          <a:lstStyle/>
-          <a:p>
-            <a:r>
-              <a:rPr sz="1500" b="1" i="0">
-                <a:solidFill>
-                  <a:srgbClr val="101826"/>
-                </a:solidFill>
-                <a:latin typeface="Calibri"/>
-              </a:rPr>
-              <a:t>Nasıl Çalıştığını Öğrendiğim Katmanlar</a:t>
-            </a:r>
-          </a:p>
-        </p:txBody>
-      </p:sp>
-      <p:sp>
-        <p:nvSpPr>
-          <p:cNvPr id="19" name="Rounded Rectangle 18"/>
-          <p:cNvSpPr/>
-          <p:nvPr/>
-        </p:nvSpPr>
-        <p:spPr>
-          <a:xfrm>
-            <a:off x="6434175" y="2962656"/>
-            <a:ext cx="676656" cy="274320"/>
-          </a:xfrm>
-          <a:prstGeom prst="roundRect">
-            <a:avLst>
-              <a:gd name="adj" fmla="val 50000"/>
-            </a:avLst>
-          </a:prstGeom>
-          <a:solidFill>
-            <a:srgbClr val="E7ECF5"/>
-          </a:solidFill>
-          <a:ln w="9525">
-            <a:solidFill>
-              <a:srgbClr val="004694"/>
-            </a:solidFill>
-          </a:ln>
-          <a:effectLst/>
-        </p:spPr>
-        <p:style>
-          <a:lnRef idx="1">
-            <a:schemeClr val="accent1"/>
-          </a:lnRef>
-          <a:fillRef idx="3">
-            <a:schemeClr val="accent1"/>
-          </a:fillRef>
-          <a:effectRef idx="2">
-            <a:schemeClr val="accent1"/>
-          </a:effectRef>
-          <a:fontRef idx="minor">
-            <a:schemeClr val="lt1"/>
-          </a:fontRef>
-        </p:style>
-        <p:txBody>
-          <a:bodyPr rtlCol="0" anchor="ctr" lIns="0" rIns="0" tIns="0" bIns="0"/>
-          <a:lstStyle/>
-          <a:p>
-            <a:pPr algn="ctr"/>
-            <a:r>
-              <a:rPr sz="1000" b="1" i="0">
-                <a:solidFill>
-                  <a:srgbClr val="004694"/>
+              <a:t>ETH_Status_t ETH_PHY_Bringup(uint8_t addr) {</a:t>
+            </a:r>
+          </a:p>
+          <a:p>
+            <a:pPr>
+              <a:spcAft>
+                <a:spcPts val="100"/>
+              </a:spcAft>
+            </a:pPr>
+            <a:r>
+              <a:rPr sz="900" b="0" i="0">
+                <a:solidFill>
+                  <a:srgbClr val="DBE8FB"/>
                 </a:solidFill>
                 <a:latin typeface="Consolas"/>
               </a:rPr>
-              <a:t>DMA</a:t>
-            </a:r>
-          </a:p>
-        </p:txBody>
-      </p:sp>
-      <p:sp>
-        <p:nvSpPr>
-          <p:cNvPr id="20" name="Rounded Rectangle 19"/>
-          <p:cNvSpPr/>
-          <p:nvPr/>
-        </p:nvSpPr>
-        <p:spPr>
-          <a:xfrm>
-            <a:off x="7220559" y="2962656"/>
-            <a:ext cx="3054096" cy="274320"/>
-          </a:xfrm>
-          <a:prstGeom prst="roundRect">
-            <a:avLst>
-              <a:gd name="adj" fmla="val 50000"/>
-            </a:avLst>
-          </a:prstGeom>
-          <a:solidFill>
-            <a:srgbClr val="E7ECF5"/>
-          </a:solidFill>
-          <a:ln w="9525">
-            <a:solidFill>
-              <a:srgbClr val="004694"/>
-            </a:solidFill>
-          </a:ln>
-          <a:effectLst/>
-        </p:spPr>
-        <p:style>
-          <a:lnRef idx="1">
-            <a:schemeClr val="accent1"/>
-          </a:lnRef>
-          <a:fillRef idx="3">
-            <a:schemeClr val="accent1"/>
-          </a:fillRef>
-          <a:effectRef idx="2">
-            <a:schemeClr val="accent1"/>
-          </a:effectRef>
-          <a:fontRef idx="minor">
-            <a:schemeClr val="lt1"/>
-          </a:fontRef>
-        </p:style>
-        <p:txBody>
-          <a:bodyPr rtlCol="0" anchor="ctr" lIns="0" rIns="0" tIns="0" bIns="0"/>
-          <a:lstStyle/>
-          <a:p>
-            <a:pPr algn="ctr"/>
-            <a:r>
-              <a:rPr sz="1000" b="1" i="0">
-                <a:solidFill>
-                  <a:srgbClr val="004694"/>
+              <a:t>    /* HW+SW reset, autoneg baslat */</a:t>
+            </a:r>
+          </a:p>
+          <a:p>
+            <a:pPr>
+              <a:spcAft>
+                <a:spcPts val="100"/>
+              </a:spcAft>
+            </a:pPr>
+            <a:r>
+              <a:rPr sz="900" b="0" i="0">
+                <a:solidFill>
+                  <a:srgbClr val="DBE8FB"/>
                 </a:solidFill>
                 <a:latin typeface="Consolas"/>
               </a:rPr>
-              <a:t>Ethernet (MAC/PHY/RMII)</a:t>
-            </a:r>
-          </a:p>
-        </p:txBody>
-      </p:sp>
-      <p:sp>
-        <p:nvSpPr>
-          <p:cNvPr id="21" name="Rounded Rectangle 20"/>
-          <p:cNvSpPr/>
-          <p:nvPr/>
-        </p:nvSpPr>
-        <p:spPr>
-          <a:xfrm>
-            <a:off x="10384383" y="2962656"/>
-            <a:ext cx="676656" cy="274320"/>
-          </a:xfrm>
-          <a:prstGeom prst="roundRect">
-            <a:avLst>
-              <a:gd name="adj" fmla="val 50000"/>
-            </a:avLst>
-          </a:prstGeom>
-          <a:solidFill>
-            <a:srgbClr val="E7ECF5"/>
-          </a:solidFill>
-          <a:ln w="9525">
-            <a:solidFill>
-              <a:srgbClr val="004694"/>
-            </a:solidFill>
-          </a:ln>
-          <a:effectLst/>
-        </p:spPr>
-        <p:style>
-          <a:lnRef idx="1">
-            <a:schemeClr val="accent1"/>
-          </a:lnRef>
-          <a:fillRef idx="3">
-            <a:schemeClr val="accent1"/>
-          </a:fillRef>
-          <a:effectRef idx="2">
-            <a:schemeClr val="accent1"/>
-          </a:effectRef>
-          <a:fontRef idx="minor">
-            <a:schemeClr val="lt1"/>
-          </a:fontRef>
-        </p:style>
-        <p:txBody>
-          <a:bodyPr rtlCol="0" anchor="ctr" lIns="0" rIns="0" tIns="0" bIns="0"/>
-          <a:lstStyle/>
-          <a:p>
-            <a:pPr algn="ctr"/>
-            <a:r>
-              <a:rPr sz="1000" b="1" i="0">
-                <a:solidFill>
-                  <a:srgbClr val="004694"/>
+              <a:t>}</a:t>
+            </a:r>
+          </a:p>
+          <a:p>
+            <a:pPr>
+              <a:spcAft>
+                <a:spcPts val="100"/>
+              </a:spcAft>
+            </a:pPr>
+            <a:r>
+              <a:rPr sz="900" b="0" i="0">
+                <a:solidFill>
+                  <a:srgbClr val="DBE8FB"/>
                 </a:solidFill>
                 <a:latin typeface="Consolas"/>
               </a:rPr>
-              <a:t>I2C</a:t>
-            </a:r>
-          </a:p>
-        </p:txBody>
-      </p:sp>
-      <p:sp>
-        <p:nvSpPr>
-          <p:cNvPr id="22" name="Rounded Rectangle 21"/>
-          <p:cNvSpPr/>
-          <p:nvPr/>
-        </p:nvSpPr>
-        <p:spPr>
-          <a:xfrm>
-            <a:off x="6434175" y="3291840"/>
-            <a:ext cx="676656" cy="274320"/>
-          </a:xfrm>
-          <a:prstGeom prst="roundRect">
-            <a:avLst>
-              <a:gd name="adj" fmla="val 50000"/>
-            </a:avLst>
-          </a:prstGeom>
-          <a:solidFill>
-            <a:srgbClr val="E7ECF5"/>
-          </a:solidFill>
-          <a:ln w="9525">
-            <a:solidFill>
-              <a:srgbClr val="004694"/>
-            </a:solidFill>
-          </a:ln>
-          <a:effectLst/>
-        </p:spPr>
-        <p:style>
-          <a:lnRef idx="1">
-            <a:schemeClr val="accent1"/>
-          </a:lnRef>
-          <a:fillRef idx="3">
-            <a:schemeClr val="accent1"/>
-          </a:fillRef>
-          <a:effectRef idx="2">
-            <a:schemeClr val="accent1"/>
-          </a:effectRef>
-          <a:fontRef idx="minor">
-            <a:schemeClr val="lt1"/>
-          </a:fontRef>
-        </p:style>
-        <p:txBody>
-          <a:bodyPr rtlCol="0" anchor="ctr" lIns="0" rIns="0" tIns="0" bIns="0"/>
-          <a:lstStyle/>
-          <a:p>
-            <a:pPr algn="ctr"/>
-            <a:r>
-              <a:rPr sz="1000" b="1" i="0">
-                <a:solidFill>
-                  <a:srgbClr val="004694"/>
+              <a:t>ETH_Status_t ETH_PHY_GetSpeedDuplex(uint8_t addr,</a:t>
+            </a:r>
+          </a:p>
+          <a:p>
+            <a:pPr>
+              <a:spcAft>
+                <a:spcPts val="100"/>
+              </a:spcAft>
+            </a:pPr>
+            <a:r>
+              <a:rPr sz="900" b="0" i="0">
+                <a:solidFill>
+                  <a:srgbClr val="DBE8FB"/>
                 </a:solidFill>
                 <a:latin typeface="Consolas"/>
               </a:rPr>
-              <a:t>SPI</a:t>
-            </a:r>
-          </a:p>
-        </p:txBody>
-      </p:sp>
-      <p:sp>
-        <p:nvSpPr>
-          <p:cNvPr id="23" name="Rounded Rectangle 22"/>
-          <p:cNvSpPr/>
-          <p:nvPr/>
-        </p:nvSpPr>
-        <p:spPr>
-          <a:xfrm>
-            <a:off x="7220559" y="3291840"/>
-            <a:ext cx="795528" cy="274320"/>
-          </a:xfrm>
-          <a:prstGeom prst="roundRect">
-            <a:avLst>
-              <a:gd name="adj" fmla="val 50000"/>
-            </a:avLst>
-          </a:prstGeom>
-          <a:solidFill>
-            <a:srgbClr val="E7ECF5"/>
-          </a:solidFill>
-          <a:ln w="9525">
-            <a:solidFill>
-              <a:srgbClr val="004694"/>
-            </a:solidFill>
-          </a:ln>
-          <a:effectLst/>
-        </p:spPr>
-        <p:style>
-          <a:lnRef idx="1">
-            <a:schemeClr val="accent1"/>
-          </a:lnRef>
-          <a:fillRef idx="3">
-            <a:schemeClr val="accent1"/>
-          </a:fillRef>
-          <a:effectRef idx="2">
-            <a:schemeClr val="accent1"/>
-          </a:effectRef>
-          <a:fontRef idx="minor">
-            <a:schemeClr val="lt1"/>
-          </a:fontRef>
-        </p:style>
-        <p:txBody>
-          <a:bodyPr rtlCol="0" anchor="ctr" lIns="0" rIns="0" tIns="0" bIns="0"/>
-          <a:lstStyle/>
-          <a:p>
-            <a:pPr algn="ctr"/>
-            <a:r>
-              <a:rPr sz="1000" b="1" i="0">
-                <a:solidFill>
-                  <a:srgbClr val="004694"/>
+              <a:t>        uint16_t *speed, bool *fd) { ... }</a:t>
+            </a:r>
+          </a:p>
+          <a:p>
+            <a:pPr>
+              <a:spcAft>
+                <a:spcPts val="100"/>
+              </a:spcAft>
+            </a:pPr>
+            <a:r>
+              <a:rPr sz="900" b="0" i="0">
+                <a:solidFill>
+                  <a:srgbClr val="DBE8FB"/>
                 </a:solidFill>
                 <a:latin typeface="Consolas"/>
               </a:rPr>
-              <a:t>UART</a:t>
-            </a:r>
-          </a:p>
-        </p:txBody>
-      </p:sp>
-      <p:sp>
-        <p:nvSpPr>
-          <p:cNvPr id="24" name="Rounded Rectangle 23"/>
-          <p:cNvSpPr/>
-          <p:nvPr/>
-        </p:nvSpPr>
-        <p:spPr>
-          <a:xfrm>
-            <a:off x="8125815" y="3291840"/>
-            <a:ext cx="2221992" cy="274320"/>
-          </a:xfrm>
-          <a:prstGeom prst="roundRect">
-            <a:avLst>
-              <a:gd name="adj" fmla="val 50000"/>
-            </a:avLst>
-          </a:prstGeom>
-          <a:solidFill>
-            <a:srgbClr val="E7ECF5"/>
-          </a:solidFill>
-          <a:ln w="9525">
-            <a:solidFill>
-              <a:srgbClr val="004694"/>
-            </a:solidFill>
-          </a:ln>
-          <a:effectLst/>
-        </p:spPr>
-        <p:style>
-          <a:lnRef idx="1">
-            <a:schemeClr val="accent1"/>
-          </a:lnRef>
-          <a:fillRef idx="3">
-            <a:schemeClr val="accent1"/>
-          </a:fillRef>
-          <a:effectRef idx="2">
-            <a:schemeClr val="accent1"/>
-          </a:effectRef>
-          <a:fontRef idx="minor">
-            <a:schemeClr val="lt1"/>
-          </a:fontRef>
-        </p:style>
-        <p:txBody>
-          <a:bodyPr rtlCol="0" anchor="ctr" lIns="0" rIns="0" tIns="0" bIns="0"/>
-          <a:lstStyle/>
-          <a:p>
-            <a:pPr algn="ctr"/>
-            <a:r>
-              <a:rPr sz="1000" b="1" i="0">
-                <a:solidFill>
-                  <a:srgbClr val="004694"/>
+              <a:t>ETH_Status_t ETH_PHY_SetLoopback(uint8_t a, bool e) { ... }</a:t>
+            </a:r>
+          </a:p>
+          <a:p>
+            <a:pPr>
+              <a:spcAft>
+                <a:spcPts val="100"/>
+              </a:spcAft>
+            </a:pPr>
+            <a:r>
+              <a:rPr sz="900" b="0" i="0">
+                <a:solidFill>
+                  <a:srgbClr val="DBE8FB"/>
                 </a:solidFill>
                 <a:latin typeface="Consolas"/>
               </a:rPr>
-              <a:t>Interrupt (NVIC)</a:t>
-            </a:r>
-          </a:p>
-        </p:txBody>
-      </p:sp>
-      <p:sp>
-        <p:nvSpPr>
-          <p:cNvPr id="25" name="Rounded Rectangle 24"/>
-          <p:cNvSpPr/>
-          <p:nvPr/>
-        </p:nvSpPr>
-        <p:spPr>
-          <a:xfrm>
-            <a:off x="6434175" y="3621024"/>
-            <a:ext cx="2459736" cy="274320"/>
-          </a:xfrm>
-          <a:prstGeom prst="roundRect">
-            <a:avLst>
-              <a:gd name="adj" fmla="val 50000"/>
-            </a:avLst>
-          </a:prstGeom>
-          <a:solidFill>
-            <a:srgbClr val="E7ECF5"/>
-          </a:solidFill>
-          <a:ln w="9525">
-            <a:solidFill>
-              <a:srgbClr val="004694"/>
-            </a:solidFill>
-          </a:ln>
-          <a:effectLst/>
-        </p:spPr>
-        <p:style>
-          <a:lnRef idx="1">
-            <a:schemeClr val="accent1"/>
-          </a:lnRef>
-          <a:fillRef idx="3">
-            <a:schemeClr val="accent1"/>
-          </a:fillRef>
-          <a:effectRef idx="2">
-            <a:schemeClr val="accent1"/>
-          </a:effectRef>
-          <a:fontRef idx="minor">
-            <a:schemeClr val="lt1"/>
-          </a:fontRef>
-        </p:style>
-        <p:txBody>
-          <a:bodyPr rtlCol="0" anchor="ctr" lIns="0" rIns="0" tIns="0" bIns="0"/>
-          <a:lstStyle/>
-          <a:p>
-            <a:pPr algn="ctr"/>
-            <a:r>
-              <a:rPr sz="1000" b="1" i="0">
-                <a:solidFill>
-                  <a:srgbClr val="004694"/>
+              <a:t>const char *ETH_PHY_GetName(void) {</a:t>
+            </a:r>
+          </a:p>
+          <a:p>
+            <a:pPr>
+              <a:spcAft>
+                <a:spcPts val="100"/>
+              </a:spcAft>
+            </a:pPr>
+            <a:r>
+              <a:rPr sz="900" b="0" i="0">
+                <a:solidFill>
+                  <a:srgbClr val="DBE8FB"/>
                 </a:solidFill>
                 <a:latin typeface="Consolas"/>
               </a:rPr>
-              <a:t>FreeRTOS temelleri</a:t>
-            </a:r>
-          </a:p>
-        </p:txBody>
-      </p:sp>
-      <p:sp>
-        <p:nvSpPr>
-          <p:cNvPr id="26" name="TextBox 25"/>
-          <p:cNvSpPr txBox="1"/>
-          <p:nvPr/>
-        </p:nvSpPr>
-        <p:spPr>
-          <a:xfrm>
-            <a:off x="502920" y="5120640"/>
-            <a:ext cx="11185855" cy="457200"/>
-          </a:xfrm>
-          <a:prstGeom prst="rect">
-            <a:avLst/>
-          </a:prstGeom>
-          <a:noFill/>
-        </p:spPr>
-        <p:txBody>
-          <a:bodyPr wrap="square" lIns="0" rIns="0" tIns="0" bIns="0">
-            <a:spAutoFit/>
-          </a:bodyPr>
-          <a:lstStyle/>
-          <a:p>
-            <a:pPr algn="ctr"/>
-            <a:r>
-              <a:rPr sz="1150" b="0" i="1">
-                <a:solidFill>
-                  <a:srgbClr val="5B6B80"/>
-                </a:solidFill>
-                <a:latin typeface="Calibri"/>
-              </a:rPr>
-              <a:t>Bare-metal kod yazma pratiği + farklı işlemci çekirdeklerini (Cortex-M4/M7/M33) ve farklı entegreleri tek bir projede bir araya getirme deneyimi.</a:t>
+              <a:t>    return "YENI_PHY";</a:t>
+            </a:r>
+          </a:p>
+          <a:p>
+            <a:pPr>
+              <a:spcAft>
+                <a:spcPts val="100"/>
+              </a:spcAft>
+            </a:pPr>
+            <a:r>
+              <a:rPr sz="900" b="0" i="0">
+                <a:solidFill>
+                  <a:srgbClr val="DBE8FB"/>
+                </a:solidFill>
+                <a:latin typeface="Consolas"/>
+              </a:rPr>
+              <a:t>}</a:t>
             </a:r>
           </a:p>
         </p:txBody>
@@ -5908,7 +5912,7 @@
                 </a:solidFill>
                 <a:latin typeface="Consolas"/>
               </a:rPr>
-              <a:t>13 · KAZANIMLAR</a:t>
+              <a:t>13 · ARAÇLAR &amp; TEKNOLOJILER</a:t>
             </a:r>
           </a:p>
         </p:txBody>
@@ -5942,7 +5946,7 @@
                 </a:solidFill>
                 <a:latin typeface="Calibri"/>
               </a:rPr>
-              <a:t>Bu stajın ve projenin bana kattıkları</a:t>
+              <a:t>Tek projede birçok farklı teknolojiyi bir araya getirdim</a:t>
             </a:r>
           </a:p>
         </p:txBody>
@@ -5976,7 +5980,7 @@
                 </a:solidFill>
                 <a:latin typeface="Calibri"/>
               </a:rPr>
-              <a:t>Eğitimle başlayıp gereksinimden teste uzanan tam bir mühendislik döngüsünü, tek bir projede kendi ellerimle tamamladım — üç boyutta öğrenme ve somut bir çıktı.</a:t>
+              <a:t>Sadece C kodu yazmadım; geliştirme ortamından donanım protokollerine kadar birçok konuda uygulamalı pratik yaptım.</a:t>
             </a:r>
           </a:p>
         </p:txBody>
@@ -6045,7 +6049,1171 @@
                 </a:solidFill>
                 <a:latin typeface="Calibri"/>
               </a:rPr>
-              <a:t>14 / 14</a:t>
+              <a:t>14 / 15</a:t>
+            </a:r>
+          </a:p>
+        </p:txBody>
+      </p:sp>
+      <p:sp>
+        <p:nvSpPr>
+          <p:cNvPr id="8" name="Rounded Rectangle 7"/>
+          <p:cNvSpPr/>
+          <p:nvPr/>
+        </p:nvSpPr>
+        <p:spPr>
+          <a:xfrm>
+            <a:off x="502920" y="2103120"/>
+            <a:ext cx="5455767" cy="2834640"/>
+          </a:xfrm>
+          <a:prstGeom prst="roundRect">
+            <a:avLst>
+              <a:gd name="adj" fmla="val 4500"/>
+            </a:avLst>
+          </a:prstGeom>
+          <a:solidFill>
+            <a:srgbClr val="F6F8FB"/>
+          </a:solidFill>
+          <a:ln w="12700">
+            <a:solidFill>
+              <a:srgbClr val="DBE1EA"/>
+            </a:solidFill>
+          </a:ln>
+          <a:effectLst/>
+        </p:spPr>
+        <p:style>
+          <a:lnRef idx="1">
+            <a:schemeClr val="accent1"/>
+          </a:lnRef>
+          <a:fillRef idx="3">
+            <a:schemeClr val="accent1"/>
+          </a:fillRef>
+          <a:effectRef idx="2">
+            <a:schemeClr val="accent1"/>
+          </a:effectRef>
+          <a:fontRef idx="minor">
+            <a:schemeClr val="lt1"/>
+          </a:fontRef>
+        </p:style>
+        <p:txBody>
+          <a:bodyPr rtlCol="0" anchor="ctr"/>
+          <a:lstStyle/>
+          <a:p>
+            <a:pPr algn="ctr"/>
+          </a:p>
+        </p:txBody>
+      </p:sp>
+      <p:sp>
+        <p:nvSpPr>
+          <p:cNvPr id="9" name="TextBox 8"/>
+          <p:cNvSpPr txBox="1"/>
+          <p:nvPr/>
+        </p:nvSpPr>
+        <p:spPr>
+          <a:xfrm>
+            <a:off x="704088" y="2304288"/>
+            <a:ext cx="5053431" cy="219456"/>
+          </a:xfrm>
+          <a:prstGeom prst="rect">
+            <a:avLst/>
+          </a:prstGeom>
+          <a:noFill/>
+        </p:spPr>
+        <p:txBody>
+          <a:bodyPr wrap="square" lIns="0" rIns="0" tIns="0" bIns="0">
+            <a:spAutoFit/>
+          </a:bodyPr>
+          <a:lstStyle/>
+          <a:p>
+            <a:r>
+              <a:rPr sz="950" b="1" i="0">
+                <a:solidFill>
+                  <a:srgbClr val="0E93B4"/>
+                </a:solidFill>
+                <a:latin typeface="Consolas"/>
+              </a:rPr>
+              <a:t>GELIŞTIRME ORTAMI</a:t>
+            </a:r>
+          </a:p>
+        </p:txBody>
+      </p:sp>
+      <p:sp>
+        <p:nvSpPr>
+          <p:cNvPr id="10" name="TextBox 9"/>
+          <p:cNvSpPr txBox="1"/>
+          <p:nvPr/>
+        </p:nvSpPr>
+        <p:spPr>
+          <a:xfrm>
+            <a:off x="704088" y="2578608"/>
+            <a:ext cx="5053431" cy="320040"/>
+          </a:xfrm>
+          <a:prstGeom prst="rect">
+            <a:avLst/>
+          </a:prstGeom>
+          <a:noFill/>
+        </p:spPr>
+        <p:txBody>
+          <a:bodyPr wrap="square" lIns="0" rIns="0" tIns="0" bIns="0">
+            <a:spAutoFit/>
+          </a:bodyPr>
+          <a:lstStyle/>
+          <a:p>
+            <a:r>
+              <a:rPr sz="1500" b="1" i="0">
+                <a:solidFill>
+                  <a:srgbClr val="101826"/>
+                </a:solidFill>
+                <a:latin typeface="Calibri"/>
+              </a:rPr>
+              <a:t>Araçlar &amp; İş Akışı</a:t>
+            </a:r>
+          </a:p>
+        </p:txBody>
+      </p:sp>
+      <p:sp>
+        <p:nvSpPr>
+          <p:cNvPr id="11" name="Rounded Rectangle 10"/>
+          <p:cNvSpPr/>
+          <p:nvPr/>
+        </p:nvSpPr>
+        <p:spPr>
+          <a:xfrm>
+            <a:off x="704088" y="2962656"/>
+            <a:ext cx="914400" cy="274320"/>
+          </a:xfrm>
+          <a:prstGeom prst="roundRect">
+            <a:avLst>
+              <a:gd name="adj" fmla="val 50000"/>
+            </a:avLst>
+          </a:prstGeom>
+          <a:solidFill>
+            <a:srgbClr val="E7ECF5"/>
+          </a:solidFill>
+          <a:ln w="9525">
+            <a:solidFill>
+              <a:srgbClr val="004694"/>
+            </a:solidFill>
+          </a:ln>
+          <a:effectLst/>
+        </p:spPr>
+        <p:style>
+          <a:lnRef idx="1">
+            <a:schemeClr val="accent1"/>
+          </a:lnRef>
+          <a:fillRef idx="3">
+            <a:schemeClr val="accent1"/>
+          </a:fillRef>
+          <a:effectRef idx="2">
+            <a:schemeClr val="accent1"/>
+          </a:effectRef>
+          <a:fontRef idx="minor">
+            <a:schemeClr val="lt1"/>
+          </a:fontRef>
+        </p:style>
+        <p:txBody>
+          <a:bodyPr rtlCol="0" anchor="ctr" lIns="0" rIns="0" tIns="0" bIns="0"/>
+          <a:lstStyle/>
+          <a:p>
+            <a:pPr algn="ctr"/>
+            <a:r>
+              <a:rPr sz="1000" b="1" i="0">
+                <a:solidFill>
+                  <a:srgbClr val="004694"/>
+                </a:solidFill>
+                <a:latin typeface="Consolas"/>
+              </a:rPr>
+              <a:t>CMake</a:t>
+            </a:r>
+          </a:p>
+        </p:txBody>
+      </p:sp>
+      <p:sp>
+        <p:nvSpPr>
+          <p:cNvPr id="12" name="Rounded Rectangle 11"/>
+          <p:cNvSpPr/>
+          <p:nvPr/>
+        </p:nvSpPr>
+        <p:spPr>
+          <a:xfrm>
+            <a:off x="1728216" y="2962656"/>
+            <a:ext cx="676656" cy="274320"/>
+          </a:xfrm>
+          <a:prstGeom prst="roundRect">
+            <a:avLst>
+              <a:gd name="adj" fmla="val 50000"/>
+            </a:avLst>
+          </a:prstGeom>
+          <a:solidFill>
+            <a:srgbClr val="E7ECF5"/>
+          </a:solidFill>
+          <a:ln w="9525">
+            <a:solidFill>
+              <a:srgbClr val="004694"/>
+            </a:solidFill>
+          </a:ln>
+          <a:effectLst/>
+        </p:spPr>
+        <p:style>
+          <a:lnRef idx="1">
+            <a:schemeClr val="accent1"/>
+          </a:lnRef>
+          <a:fillRef idx="3">
+            <a:schemeClr val="accent1"/>
+          </a:fillRef>
+          <a:effectRef idx="2">
+            <a:schemeClr val="accent1"/>
+          </a:effectRef>
+          <a:fontRef idx="minor">
+            <a:schemeClr val="lt1"/>
+          </a:fontRef>
+        </p:style>
+        <p:txBody>
+          <a:bodyPr rtlCol="0" anchor="ctr" lIns="0" rIns="0" tIns="0" bIns="0"/>
+          <a:lstStyle/>
+          <a:p>
+            <a:pPr algn="ctr"/>
+            <a:r>
+              <a:rPr sz="1000" b="1" i="0">
+                <a:solidFill>
+                  <a:srgbClr val="004694"/>
+                </a:solidFill>
+                <a:latin typeface="Consolas"/>
+              </a:rPr>
+              <a:t>Git</a:t>
+            </a:r>
+          </a:p>
+        </p:txBody>
+      </p:sp>
+      <p:sp>
+        <p:nvSpPr>
+          <p:cNvPr id="13" name="Rounded Rectangle 12"/>
+          <p:cNvSpPr/>
+          <p:nvPr/>
+        </p:nvSpPr>
+        <p:spPr>
+          <a:xfrm>
+            <a:off x="2514600" y="2962656"/>
+            <a:ext cx="1627632" cy="274320"/>
+          </a:xfrm>
+          <a:prstGeom prst="roundRect">
+            <a:avLst>
+              <a:gd name="adj" fmla="val 50000"/>
+            </a:avLst>
+          </a:prstGeom>
+          <a:solidFill>
+            <a:srgbClr val="E7ECF5"/>
+          </a:solidFill>
+          <a:ln w="9525">
+            <a:solidFill>
+              <a:srgbClr val="004694"/>
+            </a:solidFill>
+          </a:ln>
+          <a:effectLst/>
+        </p:spPr>
+        <p:style>
+          <a:lnRef idx="1">
+            <a:schemeClr val="accent1"/>
+          </a:lnRef>
+          <a:fillRef idx="3">
+            <a:schemeClr val="accent1"/>
+          </a:fillRef>
+          <a:effectRef idx="2">
+            <a:schemeClr val="accent1"/>
+          </a:effectRef>
+          <a:fontRef idx="minor">
+            <a:schemeClr val="lt1"/>
+          </a:fontRef>
+        </p:style>
+        <p:txBody>
+          <a:bodyPr rtlCol="0" anchor="ctr" lIns="0" rIns="0" tIns="0" bIns="0"/>
+          <a:lstStyle/>
+          <a:p>
+            <a:pPr algn="ctr"/>
+            <a:r>
+              <a:rPr sz="1000" b="1" i="0">
+                <a:solidFill>
+                  <a:srgbClr val="004694"/>
+                </a:solidFill>
+                <a:latin typeface="Consolas"/>
+              </a:rPr>
+              <a:t>GCC &amp; Ninja</a:t>
+            </a:r>
+          </a:p>
+        </p:txBody>
+      </p:sp>
+      <p:sp>
+        <p:nvSpPr>
+          <p:cNvPr id="14" name="Rounded Rectangle 13"/>
+          <p:cNvSpPr/>
+          <p:nvPr/>
+        </p:nvSpPr>
+        <p:spPr>
+          <a:xfrm>
+            <a:off x="704088" y="3291840"/>
+            <a:ext cx="1627632" cy="274320"/>
+          </a:xfrm>
+          <a:prstGeom prst="roundRect">
+            <a:avLst>
+              <a:gd name="adj" fmla="val 50000"/>
+            </a:avLst>
+          </a:prstGeom>
+          <a:solidFill>
+            <a:srgbClr val="E7ECF5"/>
+          </a:solidFill>
+          <a:ln w="9525">
+            <a:solidFill>
+              <a:srgbClr val="004694"/>
+            </a:solidFill>
+          </a:ln>
+          <a:effectLst/>
+        </p:spPr>
+        <p:style>
+          <a:lnRef idx="1">
+            <a:schemeClr val="accent1"/>
+          </a:lnRef>
+          <a:fillRef idx="3">
+            <a:schemeClr val="accent1"/>
+          </a:fillRef>
+          <a:effectRef idx="2">
+            <a:schemeClr val="accent1"/>
+          </a:effectRef>
+          <a:fontRef idx="minor">
+            <a:schemeClr val="lt1"/>
+          </a:fontRef>
+        </p:style>
+        <p:txBody>
+          <a:bodyPr rtlCol="0" anchor="ctr" lIns="0" rIns="0" tIns="0" bIns="0"/>
+          <a:lstStyle/>
+          <a:p>
+            <a:pPr algn="ctr"/>
+            <a:r>
+              <a:rPr sz="1000" b="1" i="0">
+                <a:solidFill>
+                  <a:srgbClr val="004694"/>
+                </a:solidFill>
+                <a:latin typeface="Consolas"/>
+              </a:rPr>
+              <a:t>STM32CubeMX</a:t>
+            </a:r>
+          </a:p>
+        </p:txBody>
+      </p:sp>
+      <p:sp>
+        <p:nvSpPr>
+          <p:cNvPr id="15" name="Rounded Rectangle 14"/>
+          <p:cNvSpPr/>
+          <p:nvPr/>
+        </p:nvSpPr>
+        <p:spPr>
+          <a:xfrm>
+            <a:off x="2441448" y="3291840"/>
+            <a:ext cx="1152144" cy="274320"/>
+          </a:xfrm>
+          <a:prstGeom prst="roundRect">
+            <a:avLst>
+              <a:gd name="adj" fmla="val 50000"/>
+            </a:avLst>
+          </a:prstGeom>
+          <a:solidFill>
+            <a:srgbClr val="E7ECF5"/>
+          </a:solidFill>
+          <a:ln w="9525">
+            <a:solidFill>
+              <a:srgbClr val="004694"/>
+            </a:solidFill>
+          </a:ln>
+          <a:effectLst/>
+        </p:spPr>
+        <p:style>
+          <a:lnRef idx="1">
+            <a:schemeClr val="accent1"/>
+          </a:lnRef>
+          <a:fillRef idx="3">
+            <a:schemeClr val="accent1"/>
+          </a:fillRef>
+          <a:effectRef idx="2">
+            <a:schemeClr val="accent1"/>
+          </a:effectRef>
+          <a:fontRef idx="minor">
+            <a:schemeClr val="lt1"/>
+          </a:fontRef>
+        </p:style>
+        <p:txBody>
+          <a:bodyPr rtlCol="0" anchor="ctr" lIns="0" rIns="0" tIns="0" bIns="0"/>
+          <a:lstStyle/>
+          <a:p>
+            <a:pPr algn="ctr"/>
+            <a:r>
+              <a:rPr sz="1000" b="1" i="0">
+                <a:solidFill>
+                  <a:srgbClr val="004694"/>
+                </a:solidFill>
+                <a:latin typeface="Consolas"/>
+              </a:rPr>
+              <a:t>VS Code</a:t>
+            </a:r>
+          </a:p>
+        </p:txBody>
+      </p:sp>
+      <p:sp>
+        <p:nvSpPr>
+          <p:cNvPr id="16" name="Rounded Rectangle 15"/>
+          <p:cNvSpPr/>
+          <p:nvPr/>
+        </p:nvSpPr>
+        <p:spPr>
+          <a:xfrm>
+            <a:off x="6233007" y="2103120"/>
+            <a:ext cx="5455767" cy="2834640"/>
+          </a:xfrm>
+          <a:prstGeom prst="roundRect">
+            <a:avLst>
+              <a:gd name="adj" fmla="val 4500"/>
+            </a:avLst>
+          </a:prstGeom>
+          <a:solidFill>
+            <a:srgbClr val="F6F8FB"/>
+          </a:solidFill>
+          <a:ln w="12700">
+            <a:solidFill>
+              <a:srgbClr val="DBE1EA"/>
+            </a:solidFill>
+          </a:ln>
+          <a:effectLst/>
+        </p:spPr>
+        <p:style>
+          <a:lnRef idx="1">
+            <a:schemeClr val="accent1"/>
+          </a:lnRef>
+          <a:fillRef idx="3">
+            <a:schemeClr val="accent1"/>
+          </a:fillRef>
+          <a:effectRef idx="2">
+            <a:schemeClr val="accent1"/>
+          </a:effectRef>
+          <a:fontRef idx="minor">
+            <a:schemeClr val="lt1"/>
+          </a:fontRef>
+        </p:style>
+        <p:txBody>
+          <a:bodyPr rtlCol="0" anchor="ctr"/>
+          <a:lstStyle/>
+          <a:p>
+            <a:pPr algn="ctr"/>
+          </a:p>
+        </p:txBody>
+      </p:sp>
+      <p:sp>
+        <p:nvSpPr>
+          <p:cNvPr id="17" name="TextBox 16"/>
+          <p:cNvSpPr txBox="1"/>
+          <p:nvPr/>
+        </p:nvSpPr>
+        <p:spPr>
+          <a:xfrm>
+            <a:off x="6434175" y="2304288"/>
+            <a:ext cx="5053431" cy="219456"/>
+          </a:xfrm>
+          <a:prstGeom prst="rect">
+            <a:avLst/>
+          </a:prstGeom>
+          <a:noFill/>
+        </p:spPr>
+        <p:txBody>
+          <a:bodyPr wrap="square" lIns="0" rIns="0" tIns="0" bIns="0">
+            <a:spAutoFit/>
+          </a:bodyPr>
+          <a:lstStyle/>
+          <a:p>
+            <a:r>
+              <a:rPr sz="950" b="1" i="0">
+                <a:solidFill>
+                  <a:srgbClr val="0E93B4"/>
+                </a:solidFill>
+                <a:latin typeface="Consolas"/>
+              </a:rPr>
+              <a:t>DONANIM &amp; PROTOKOLLER</a:t>
+            </a:r>
+          </a:p>
+        </p:txBody>
+      </p:sp>
+      <p:sp>
+        <p:nvSpPr>
+          <p:cNvPr id="18" name="TextBox 17"/>
+          <p:cNvSpPr txBox="1"/>
+          <p:nvPr/>
+        </p:nvSpPr>
+        <p:spPr>
+          <a:xfrm>
+            <a:off x="6434175" y="2578608"/>
+            <a:ext cx="5053431" cy="320040"/>
+          </a:xfrm>
+          <a:prstGeom prst="rect">
+            <a:avLst/>
+          </a:prstGeom>
+          <a:noFill/>
+        </p:spPr>
+        <p:txBody>
+          <a:bodyPr wrap="square" lIns="0" rIns="0" tIns="0" bIns="0">
+            <a:spAutoFit/>
+          </a:bodyPr>
+          <a:lstStyle/>
+          <a:p>
+            <a:r>
+              <a:rPr sz="1500" b="1" i="0">
+                <a:solidFill>
+                  <a:srgbClr val="101826"/>
+                </a:solidFill>
+                <a:latin typeface="Calibri"/>
+              </a:rPr>
+              <a:t>Nasıl Çalıştığını Öğrendiğim Katmanlar</a:t>
+            </a:r>
+          </a:p>
+        </p:txBody>
+      </p:sp>
+      <p:sp>
+        <p:nvSpPr>
+          <p:cNvPr id="19" name="Rounded Rectangle 18"/>
+          <p:cNvSpPr/>
+          <p:nvPr/>
+        </p:nvSpPr>
+        <p:spPr>
+          <a:xfrm>
+            <a:off x="6434175" y="2962656"/>
+            <a:ext cx="676656" cy="274320"/>
+          </a:xfrm>
+          <a:prstGeom prst="roundRect">
+            <a:avLst>
+              <a:gd name="adj" fmla="val 50000"/>
+            </a:avLst>
+          </a:prstGeom>
+          <a:solidFill>
+            <a:srgbClr val="E7ECF5"/>
+          </a:solidFill>
+          <a:ln w="9525">
+            <a:solidFill>
+              <a:srgbClr val="004694"/>
+            </a:solidFill>
+          </a:ln>
+          <a:effectLst/>
+        </p:spPr>
+        <p:style>
+          <a:lnRef idx="1">
+            <a:schemeClr val="accent1"/>
+          </a:lnRef>
+          <a:fillRef idx="3">
+            <a:schemeClr val="accent1"/>
+          </a:fillRef>
+          <a:effectRef idx="2">
+            <a:schemeClr val="accent1"/>
+          </a:effectRef>
+          <a:fontRef idx="minor">
+            <a:schemeClr val="lt1"/>
+          </a:fontRef>
+        </p:style>
+        <p:txBody>
+          <a:bodyPr rtlCol="0" anchor="ctr" lIns="0" rIns="0" tIns="0" bIns="0"/>
+          <a:lstStyle/>
+          <a:p>
+            <a:pPr algn="ctr"/>
+            <a:r>
+              <a:rPr sz="1000" b="1" i="0">
+                <a:solidFill>
+                  <a:srgbClr val="004694"/>
+                </a:solidFill>
+                <a:latin typeface="Consolas"/>
+              </a:rPr>
+              <a:t>DMA</a:t>
+            </a:r>
+          </a:p>
+        </p:txBody>
+      </p:sp>
+      <p:sp>
+        <p:nvSpPr>
+          <p:cNvPr id="20" name="Rounded Rectangle 19"/>
+          <p:cNvSpPr/>
+          <p:nvPr/>
+        </p:nvSpPr>
+        <p:spPr>
+          <a:xfrm>
+            <a:off x="7220559" y="2962656"/>
+            <a:ext cx="3054096" cy="274320"/>
+          </a:xfrm>
+          <a:prstGeom prst="roundRect">
+            <a:avLst>
+              <a:gd name="adj" fmla="val 50000"/>
+            </a:avLst>
+          </a:prstGeom>
+          <a:solidFill>
+            <a:srgbClr val="E7ECF5"/>
+          </a:solidFill>
+          <a:ln w="9525">
+            <a:solidFill>
+              <a:srgbClr val="004694"/>
+            </a:solidFill>
+          </a:ln>
+          <a:effectLst/>
+        </p:spPr>
+        <p:style>
+          <a:lnRef idx="1">
+            <a:schemeClr val="accent1"/>
+          </a:lnRef>
+          <a:fillRef idx="3">
+            <a:schemeClr val="accent1"/>
+          </a:fillRef>
+          <a:effectRef idx="2">
+            <a:schemeClr val="accent1"/>
+          </a:effectRef>
+          <a:fontRef idx="minor">
+            <a:schemeClr val="lt1"/>
+          </a:fontRef>
+        </p:style>
+        <p:txBody>
+          <a:bodyPr rtlCol="0" anchor="ctr" lIns="0" rIns="0" tIns="0" bIns="0"/>
+          <a:lstStyle/>
+          <a:p>
+            <a:pPr algn="ctr"/>
+            <a:r>
+              <a:rPr sz="1000" b="1" i="0">
+                <a:solidFill>
+                  <a:srgbClr val="004694"/>
+                </a:solidFill>
+                <a:latin typeface="Consolas"/>
+              </a:rPr>
+              <a:t>Ethernet (MAC/PHY/RMII)</a:t>
+            </a:r>
+          </a:p>
+        </p:txBody>
+      </p:sp>
+      <p:sp>
+        <p:nvSpPr>
+          <p:cNvPr id="21" name="Rounded Rectangle 20"/>
+          <p:cNvSpPr/>
+          <p:nvPr/>
+        </p:nvSpPr>
+        <p:spPr>
+          <a:xfrm>
+            <a:off x="10384383" y="2962656"/>
+            <a:ext cx="676656" cy="274320"/>
+          </a:xfrm>
+          <a:prstGeom prst="roundRect">
+            <a:avLst>
+              <a:gd name="adj" fmla="val 50000"/>
+            </a:avLst>
+          </a:prstGeom>
+          <a:solidFill>
+            <a:srgbClr val="E7ECF5"/>
+          </a:solidFill>
+          <a:ln w="9525">
+            <a:solidFill>
+              <a:srgbClr val="004694"/>
+            </a:solidFill>
+          </a:ln>
+          <a:effectLst/>
+        </p:spPr>
+        <p:style>
+          <a:lnRef idx="1">
+            <a:schemeClr val="accent1"/>
+          </a:lnRef>
+          <a:fillRef idx="3">
+            <a:schemeClr val="accent1"/>
+          </a:fillRef>
+          <a:effectRef idx="2">
+            <a:schemeClr val="accent1"/>
+          </a:effectRef>
+          <a:fontRef idx="minor">
+            <a:schemeClr val="lt1"/>
+          </a:fontRef>
+        </p:style>
+        <p:txBody>
+          <a:bodyPr rtlCol="0" anchor="ctr" lIns="0" rIns="0" tIns="0" bIns="0"/>
+          <a:lstStyle/>
+          <a:p>
+            <a:pPr algn="ctr"/>
+            <a:r>
+              <a:rPr sz="1000" b="1" i="0">
+                <a:solidFill>
+                  <a:srgbClr val="004694"/>
+                </a:solidFill>
+                <a:latin typeface="Consolas"/>
+              </a:rPr>
+              <a:t>I2C</a:t>
+            </a:r>
+          </a:p>
+        </p:txBody>
+      </p:sp>
+      <p:sp>
+        <p:nvSpPr>
+          <p:cNvPr id="22" name="Rounded Rectangle 21"/>
+          <p:cNvSpPr/>
+          <p:nvPr/>
+        </p:nvSpPr>
+        <p:spPr>
+          <a:xfrm>
+            <a:off x="6434175" y="3291840"/>
+            <a:ext cx="676656" cy="274320"/>
+          </a:xfrm>
+          <a:prstGeom prst="roundRect">
+            <a:avLst>
+              <a:gd name="adj" fmla="val 50000"/>
+            </a:avLst>
+          </a:prstGeom>
+          <a:solidFill>
+            <a:srgbClr val="E7ECF5"/>
+          </a:solidFill>
+          <a:ln w="9525">
+            <a:solidFill>
+              <a:srgbClr val="004694"/>
+            </a:solidFill>
+          </a:ln>
+          <a:effectLst/>
+        </p:spPr>
+        <p:style>
+          <a:lnRef idx="1">
+            <a:schemeClr val="accent1"/>
+          </a:lnRef>
+          <a:fillRef idx="3">
+            <a:schemeClr val="accent1"/>
+          </a:fillRef>
+          <a:effectRef idx="2">
+            <a:schemeClr val="accent1"/>
+          </a:effectRef>
+          <a:fontRef idx="minor">
+            <a:schemeClr val="lt1"/>
+          </a:fontRef>
+        </p:style>
+        <p:txBody>
+          <a:bodyPr rtlCol="0" anchor="ctr" lIns="0" rIns="0" tIns="0" bIns="0"/>
+          <a:lstStyle/>
+          <a:p>
+            <a:pPr algn="ctr"/>
+            <a:r>
+              <a:rPr sz="1000" b="1" i="0">
+                <a:solidFill>
+                  <a:srgbClr val="004694"/>
+                </a:solidFill>
+                <a:latin typeface="Consolas"/>
+              </a:rPr>
+              <a:t>SPI</a:t>
+            </a:r>
+          </a:p>
+        </p:txBody>
+      </p:sp>
+      <p:sp>
+        <p:nvSpPr>
+          <p:cNvPr id="23" name="Rounded Rectangle 22"/>
+          <p:cNvSpPr/>
+          <p:nvPr/>
+        </p:nvSpPr>
+        <p:spPr>
+          <a:xfrm>
+            <a:off x="7220559" y="3291840"/>
+            <a:ext cx="795528" cy="274320"/>
+          </a:xfrm>
+          <a:prstGeom prst="roundRect">
+            <a:avLst>
+              <a:gd name="adj" fmla="val 50000"/>
+            </a:avLst>
+          </a:prstGeom>
+          <a:solidFill>
+            <a:srgbClr val="E7ECF5"/>
+          </a:solidFill>
+          <a:ln w="9525">
+            <a:solidFill>
+              <a:srgbClr val="004694"/>
+            </a:solidFill>
+          </a:ln>
+          <a:effectLst/>
+        </p:spPr>
+        <p:style>
+          <a:lnRef idx="1">
+            <a:schemeClr val="accent1"/>
+          </a:lnRef>
+          <a:fillRef idx="3">
+            <a:schemeClr val="accent1"/>
+          </a:fillRef>
+          <a:effectRef idx="2">
+            <a:schemeClr val="accent1"/>
+          </a:effectRef>
+          <a:fontRef idx="minor">
+            <a:schemeClr val="lt1"/>
+          </a:fontRef>
+        </p:style>
+        <p:txBody>
+          <a:bodyPr rtlCol="0" anchor="ctr" lIns="0" rIns="0" tIns="0" bIns="0"/>
+          <a:lstStyle/>
+          <a:p>
+            <a:pPr algn="ctr"/>
+            <a:r>
+              <a:rPr sz="1000" b="1" i="0">
+                <a:solidFill>
+                  <a:srgbClr val="004694"/>
+                </a:solidFill>
+                <a:latin typeface="Consolas"/>
+              </a:rPr>
+              <a:t>UART</a:t>
+            </a:r>
+          </a:p>
+        </p:txBody>
+      </p:sp>
+      <p:sp>
+        <p:nvSpPr>
+          <p:cNvPr id="24" name="Rounded Rectangle 23"/>
+          <p:cNvSpPr/>
+          <p:nvPr/>
+        </p:nvSpPr>
+        <p:spPr>
+          <a:xfrm>
+            <a:off x="8125815" y="3291840"/>
+            <a:ext cx="2221992" cy="274320"/>
+          </a:xfrm>
+          <a:prstGeom prst="roundRect">
+            <a:avLst>
+              <a:gd name="adj" fmla="val 50000"/>
+            </a:avLst>
+          </a:prstGeom>
+          <a:solidFill>
+            <a:srgbClr val="E7ECF5"/>
+          </a:solidFill>
+          <a:ln w="9525">
+            <a:solidFill>
+              <a:srgbClr val="004694"/>
+            </a:solidFill>
+          </a:ln>
+          <a:effectLst/>
+        </p:spPr>
+        <p:style>
+          <a:lnRef idx="1">
+            <a:schemeClr val="accent1"/>
+          </a:lnRef>
+          <a:fillRef idx="3">
+            <a:schemeClr val="accent1"/>
+          </a:fillRef>
+          <a:effectRef idx="2">
+            <a:schemeClr val="accent1"/>
+          </a:effectRef>
+          <a:fontRef idx="minor">
+            <a:schemeClr val="lt1"/>
+          </a:fontRef>
+        </p:style>
+        <p:txBody>
+          <a:bodyPr rtlCol="0" anchor="ctr" lIns="0" rIns="0" tIns="0" bIns="0"/>
+          <a:lstStyle/>
+          <a:p>
+            <a:pPr algn="ctr"/>
+            <a:r>
+              <a:rPr sz="1000" b="1" i="0">
+                <a:solidFill>
+                  <a:srgbClr val="004694"/>
+                </a:solidFill>
+                <a:latin typeface="Consolas"/>
+              </a:rPr>
+              <a:t>Interrupt (NVIC)</a:t>
+            </a:r>
+          </a:p>
+        </p:txBody>
+      </p:sp>
+      <p:sp>
+        <p:nvSpPr>
+          <p:cNvPr id="25" name="Rounded Rectangle 24"/>
+          <p:cNvSpPr/>
+          <p:nvPr/>
+        </p:nvSpPr>
+        <p:spPr>
+          <a:xfrm>
+            <a:off x="6434175" y="3621024"/>
+            <a:ext cx="2459736" cy="274320"/>
+          </a:xfrm>
+          <a:prstGeom prst="roundRect">
+            <a:avLst>
+              <a:gd name="adj" fmla="val 50000"/>
+            </a:avLst>
+          </a:prstGeom>
+          <a:solidFill>
+            <a:srgbClr val="E7ECF5"/>
+          </a:solidFill>
+          <a:ln w="9525">
+            <a:solidFill>
+              <a:srgbClr val="004694"/>
+            </a:solidFill>
+          </a:ln>
+          <a:effectLst/>
+        </p:spPr>
+        <p:style>
+          <a:lnRef idx="1">
+            <a:schemeClr val="accent1"/>
+          </a:lnRef>
+          <a:fillRef idx="3">
+            <a:schemeClr val="accent1"/>
+          </a:fillRef>
+          <a:effectRef idx="2">
+            <a:schemeClr val="accent1"/>
+          </a:effectRef>
+          <a:fontRef idx="minor">
+            <a:schemeClr val="lt1"/>
+          </a:fontRef>
+        </p:style>
+        <p:txBody>
+          <a:bodyPr rtlCol="0" anchor="ctr" lIns="0" rIns="0" tIns="0" bIns="0"/>
+          <a:lstStyle/>
+          <a:p>
+            <a:pPr algn="ctr"/>
+            <a:r>
+              <a:rPr sz="1000" b="1" i="0">
+                <a:solidFill>
+                  <a:srgbClr val="004694"/>
+                </a:solidFill>
+                <a:latin typeface="Consolas"/>
+              </a:rPr>
+              <a:t>FreeRTOS temelleri</a:t>
+            </a:r>
+          </a:p>
+        </p:txBody>
+      </p:sp>
+      <p:sp>
+        <p:nvSpPr>
+          <p:cNvPr id="26" name="TextBox 25"/>
+          <p:cNvSpPr txBox="1"/>
+          <p:nvPr/>
+        </p:nvSpPr>
+        <p:spPr>
+          <a:xfrm>
+            <a:off x="502920" y="5120640"/>
+            <a:ext cx="11185855" cy="457200"/>
+          </a:xfrm>
+          <a:prstGeom prst="rect">
+            <a:avLst/>
+          </a:prstGeom>
+          <a:noFill/>
+        </p:spPr>
+        <p:txBody>
+          <a:bodyPr wrap="square" lIns="0" rIns="0" tIns="0" bIns="0">
+            <a:spAutoFit/>
+          </a:bodyPr>
+          <a:lstStyle/>
+          <a:p>
+            <a:pPr algn="ctr"/>
+            <a:r>
+              <a:rPr sz="1150" b="0" i="1">
+                <a:solidFill>
+                  <a:srgbClr val="5B6B80"/>
+                </a:solidFill>
+                <a:latin typeface="Calibri"/>
+              </a:rPr>
+              <a:t>Bare-metal kod yazma pratiği + farklı işlemci çekirdeklerini (Cortex-M4/M7/M33) ve farklı entegreleri tek bir projede bir araya getirme deneyimi.</a:t>
+            </a:r>
+          </a:p>
+        </p:txBody>
+      </p:sp>
+    </p:spTree>
+  </p:cSld>
+  <p:clrMapOvr>
+    <a:masterClrMapping/>
+  </p:clrMapOvr>
+</p:sld>
+</file>
+
+<file path=ppt/slides/slide15.xml><?xml version="1.0" encoding="utf-8"?>
+<p:sld xmlns:a="http://schemas.openxmlformats.org/drawingml/2006/main" xmlns:p="http://schemas.openxmlformats.org/presentationml/2006/main" xmlns:r="http://schemas.openxmlformats.org/officeDocument/2006/relationships">
+  <p:cSld>
+    <p:spTree>
+      <p:nvGrpSpPr>
+        <p:cNvPr id="1" name=""/>
+        <p:cNvGrpSpPr/>
+        <p:nvPr/>
+      </p:nvGrpSpPr>
+      <p:grpSpPr/>
+      <p:pic>
+        <p:nvPicPr>
+          <p:cNvPr id="2" name="Picture 1" descr="sunu_arka_plan.png"/>
+          <p:cNvPicPr>
+            <a:picLocks noChangeAspect="1"/>
+          </p:cNvPicPr>
+          <p:nvPr/>
+        </p:nvPicPr>
+        <p:blipFill>
+          <a:blip r:embed="rId2"/>
+          <a:stretch>
+            <a:fillRect/>
+          </a:stretch>
+        </p:blipFill>
+        <p:spPr>
+          <a:xfrm>
+            <a:off x="0" y="0"/>
+            <a:ext cx="12191695" cy="6858000"/>
+          </a:xfrm>
+          <a:prstGeom prst="rect">
+            <a:avLst/>
+          </a:prstGeom>
+        </p:spPr>
+      </p:pic>
+      <p:sp>
+        <p:nvSpPr>
+          <p:cNvPr id="3" name="TextBox 2"/>
+          <p:cNvSpPr txBox="1"/>
+          <p:nvPr/>
+        </p:nvSpPr>
+        <p:spPr>
+          <a:xfrm>
+            <a:off x="502920" y="347472"/>
+            <a:ext cx="8778240" cy="292608"/>
+          </a:xfrm>
+          <a:prstGeom prst="rect">
+            <a:avLst/>
+          </a:prstGeom>
+          <a:noFill/>
+        </p:spPr>
+        <p:txBody>
+          <a:bodyPr wrap="square" lIns="0" rIns="0" tIns="0" bIns="0">
+            <a:spAutoFit/>
+          </a:bodyPr>
+          <a:lstStyle/>
+          <a:p>
+            <a:r>
+              <a:rPr sz="1100" b="1" i="0">
+                <a:solidFill>
+                  <a:srgbClr val="0E93B4"/>
+                </a:solidFill>
+                <a:latin typeface="Consolas"/>
+              </a:rPr>
+              <a:t>14 · KAZANIMLAR</a:t>
+            </a:r>
+          </a:p>
+        </p:txBody>
+      </p:sp>
+      <p:sp>
+        <p:nvSpPr>
+          <p:cNvPr id="4" name="TextBox 3"/>
+          <p:cNvSpPr txBox="1"/>
+          <p:nvPr/>
+        </p:nvSpPr>
+        <p:spPr>
+          <a:xfrm>
+            <a:off x="502920" y="658368"/>
+            <a:ext cx="9875520" cy="960120"/>
+          </a:xfrm>
+          <a:prstGeom prst="rect">
+            <a:avLst/>
+          </a:prstGeom>
+          <a:noFill/>
+        </p:spPr>
+        <p:txBody>
+          <a:bodyPr wrap="square" lIns="0" rIns="0" tIns="0" bIns="0">
+            <a:spAutoFit/>
+          </a:bodyPr>
+          <a:lstStyle/>
+          <a:p>
+            <a:r>
+              <a:rPr sz="2700" b="1" i="0">
+                <a:solidFill>
+                  <a:srgbClr val="101826"/>
+                </a:solidFill>
+                <a:latin typeface="Calibri"/>
+              </a:rPr>
+              <a:t>Bu stajın ve projenin bana kattıkları</a:t>
+            </a:r>
+          </a:p>
+        </p:txBody>
+      </p:sp>
+      <p:sp>
+        <p:nvSpPr>
+          <p:cNvPr id="5" name="TextBox 4"/>
+          <p:cNvSpPr txBox="1"/>
+          <p:nvPr/>
+        </p:nvSpPr>
+        <p:spPr>
+          <a:xfrm>
+            <a:off x="502920" y="1417320"/>
+            <a:ext cx="10241280" cy="548640"/>
+          </a:xfrm>
+          <a:prstGeom prst="rect">
+            <a:avLst/>
+          </a:prstGeom>
+          <a:noFill/>
+        </p:spPr>
+        <p:txBody>
+          <a:bodyPr wrap="square" lIns="0" rIns="0" tIns="0" bIns="0">
+            <a:spAutoFit/>
+          </a:bodyPr>
+          <a:lstStyle/>
+          <a:p>
+            <a:r>
+              <a:rPr sz="1350" b="0" i="0">
+                <a:solidFill>
+                  <a:srgbClr val="5B6B80"/>
+                </a:solidFill>
+                <a:latin typeface="Calibri"/>
+              </a:rPr>
+              <a:t>Eğitimle başlayıp gereksinimden teste uzanan tam bir mühendislik döngüsünü, tek bir projede kendi ellerimle tamamladım — üç boyutta öğrenme ve somut bir çıktı.</a:t>
+            </a:r>
+          </a:p>
+        </p:txBody>
+      </p:sp>
+      <p:sp>
+        <p:nvSpPr>
+          <p:cNvPr id="6" name="TextBox 5"/>
+          <p:cNvSpPr txBox="1"/>
+          <p:nvPr/>
+        </p:nvSpPr>
+        <p:spPr>
+          <a:xfrm>
+            <a:off x="502920" y="6446520"/>
+            <a:ext cx="5486400" cy="274320"/>
+          </a:xfrm>
+          <a:prstGeom prst="rect">
+            <a:avLst/>
+          </a:prstGeom>
+          <a:noFill/>
+        </p:spPr>
+        <p:txBody>
+          <a:bodyPr wrap="square" lIns="0" rIns="0" tIns="0" bIns="0">
+            <a:spAutoFit/>
+          </a:bodyPr>
+          <a:lstStyle/>
+          <a:p>
+            <a:r>
+              <a:rPr sz="900" b="0" i="0">
+                <a:solidFill>
+                  <a:srgbClr val="5B6B80"/>
+                </a:solidFill>
+                <a:latin typeface="Calibri"/>
+              </a:rPr>
+              <a:t>E-AETIS · Staj Sunumu</a:t>
+            </a:r>
+          </a:p>
+        </p:txBody>
+      </p:sp>
+      <p:sp>
+        <p:nvSpPr>
+          <p:cNvPr id="7" name="TextBox 6"/>
+          <p:cNvSpPr txBox="1"/>
+          <p:nvPr/>
+        </p:nvSpPr>
+        <p:spPr>
+          <a:xfrm>
+            <a:off x="10042855" y="6446520"/>
+            <a:ext cx="1828800" cy="274320"/>
+          </a:xfrm>
+          <a:prstGeom prst="rect">
+            <a:avLst/>
+          </a:prstGeom>
+          <a:noFill/>
+        </p:spPr>
+        <p:txBody>
+          <a:bodyPr wrap="square" lIns="0" rIns="0" tIns="0" bIns="0">
+            <a:spAutoFit/>
+          </a:bodyPr>
+          <a:lstStyle/>
+          <a:p>
+            <a:pPr algn="r"/>
+            <a:r>
+              <a:rPr sz="900" b="0" i="0">
+                <a:solidFill>
+                  <a:srgbClr val="5B6B80"/>
+                </a:solidFill>
+                <a:latin typeface="Calibri"/>
+              </a:rPr>
+              <a:t>15 / 15</a:t>
             </a:r>
           </a:p>
         </p:txBody>
@@ -7088,7 +8256,7 @@
                 </a:solidFill>
                 <a:latin typeface="Calibri"/>
               </a:rPr>
-              <a:t>02 / 14</a:t>
+              <a:t>02 / 15</a:t>
             </a:r>
           </a:p>
         </p:txBody>
@@ -7762,7 +8930,7 @@
                 </a:solidFill>
                 <a:latin typeface="Calibri"/>
               </a:rPr>
-              <a:t>03 / 14</a:t>
+              <a:t>03 / 15</a:t>
             </a:r>
           </a:p>
         </p:txBody>
@@ -8543,7 +9711,7 @@
                 </a:solidFill>
                 <a:latin typeface="Calibri"/>
               </a:rPr>
-              <a:t>04 / 14</a:t>
+              <a:t>04 / 15</a:t>
             </a:r>
           </a:p>
         </p:txBody>
@@ -9191,7 +10359,7 @@
                 </a:solidFill>
                 <a:latin typeface="Calibri"/>
               </a:rPr>
-              <a:t>05 / 14</a:t>
+              <a:t>05 / 15</a:t>
             </a:r>
           </a:p>
         </p:txBody>
@@ -11481,7 +12649,7 @@
                 </a:solidFill>
                 <a:latin typeface="Calibri"/>
               </a:rPr>
-              <a:t>06 / 14</a:t>
+              <a:t>06 / 15</a:t>
             </a:r>
           </a:p>
         </p:txBody>
@@ -12405,7 +13573,7 @@
                 </a:solidFill>
                 <a:latin typeface="Calibri"/>
               </a:rPr>
-              <a:t>07 / 14</a:t>
+              <a:t>07 / 15</a:t>
             </a:r>
           </a:p>
         </p:txBody>
@@ -12950,7 +14118,7 @@
                 </a:solidFill>
                 <a:latin typeface="Calibri"/>
               </a:rPr>
-              <a:t>08 / 14</a:t>
+              <a:t>08 / 15</a:t>
             </a:r>
           </a:p>
         </p:txBody>
@@ -14596,7 +15764,7 @@
                 </a:solidFill>
                 <a:latin typeface="Calibri"/>
               </a:rPr>
-              <a:t>09 / 14</a:t>
+              <a:t>09 / 15</a:t>
             </a:r>
           </a:p>
         </p:txBody>

</xml_diff>